<commit_message>
Actualiser le tableau de bord les suivis IA et le rapport SQLite
</commit_message>
<xml_diff>
--- a/docs/rapport_projet/presentation/livrables/Presentation_Observatoire_multiagents_AgentOps.pptx
+++ b/docs/rapport_projet/presentation/livrables/Presentation_Observatoire_multiagents_AgentOps.pptx
@@ -23,6 +23,7 @@
     <p:sldId xmlns:r="http://schemas.openxmlformats.org/officeDocument/2006/relationships" id="268" r:id="Rcb31ac0d863c402e"/>
     <p:sldId xmlns:r="http://schemas.openxmlformats.org/officeDocument/2006/relationships" id="269" r:id="R27425265a0504189"/>
     <p:sldId xmlns:r="http://schemas.openxmlformats.org/officeDocument/2006/relationships" id="270" r:id="R3add9881d1d34a74"/>
+    <p:sldId xmlns:ns0="http://schemas.openxmlformats.org/officeDocument/2006/relationships" id="271" ns0:id="rIdCouches16"/>
   </p:sldIdLst>
   <p:sldSz cx="12192000" cy="6858000"/>
   <p:notesSz cx="6858000" cy="9144000"/>
@@ -1066,6 +1067,76 @@
 </p:notes>
 </file>
 
+<file path=ppt/notesSlides/notesSlide16.xml><?xml version="1.0" encoding="utf-8"?>
+<p:notes xmlns:p="http://schemas.openxmlformats.org/presentationml/2006/main">
+  <p:cSld>
+    <p:spTree>
+      <p:nvGrpSpPr>
+        <p:cNvPr id="1" name=""/>
+        <p:cNvGrpSpPr/>
+        <p:nvPr/>
+      </p:nvGrpSpPr>
+      <p:grpSpPr>
+        <a:xfrm xmlns:a="http://schemas.openxmlformats.org/drawingml/2006/main"/>
+      </p:grpSpPr>
+      <p:sp>
+        <p:nvSpPr>
+          <p:cNvPr id="2" name="Slide Image Placeholder 1"/>
+          <p:cNvSpPr>
+            <a:spLocks xmlns:a="http://schemas.openxmlformats.org/drawingml/2006/main" noGrp="1"/>
+          </p:cNvSpPr>
+          <p:nvPr>
+            <p:ph type="sldImg" idx="0"/>
+          </p:nvPr>
+        </p:nvSpPr>
+        <p:spPr/>
+      </p:sp>
+      <p:sp>
+        <p:nvSpPr>
+          <p:cNvPr id="3" name="Notes Placeholder 2"/>
+          <p:cNvSpPr>
+            <a:spLocks xmlns:a="http://schemas.openxmlformats.org/drawingml/2006/main" noGrp="1"/>
+          </p:cNvSpPr>
+          <p:nvPr>
+            <p:ph type="body" idx="1"/>
+          </p:nvPr>
+        </p:nvSpPr>
+        <p:spPr/>
+        <p:txBody>
+          <a:bodyPr xmlns:a="http://schemas.openxmlformats.org/drawingml/2006/main"/>
+          <a:lstStyle xmlns:a="http://schemas.openxmlformats.org/drawingml/2006/main"/>
+          <a:p xmlns:a="http://schemas.openxmlformats.org/drawingml/2006/main">
+            <a:r>
+              <a:t>Annexe explicative. Les cercles représentent des responsabilités conceptuelles et non une architecture de conteneurs ou une séquence. Au centre, Qwen3 utilise des instructions différentes pour quatre rôles. Ollama exécute le modèle ; CrewAI orchestre les tâches. Python réalise les calculs et vérifications, les CSV apportent les données et SQLite conserve les traces. Streamlit et Plotly montrent les résultats. AgentOps reçoit un résumé technique après exécution ; il ne mesure pas ici les appels natifs du modèle. Asana a seulement été exploré et reste facultatif, sans intégration au TP. Le tableau interactif reste en espagnol ; cette diapositive en est l’adaptation française. Source : fichier fourni capas-sistema-multiagente.html. URL : https://orbitas-observatorio.claud-ia.chatgpt.site/capas-sistema-multiagente/</a:t>
+            </a:r>
+          </a:p>
+        </p:txBody>
+      </p:sp>
+      <p:sp>
+        <p:nvSpPr>
+          <p:cNvPr id="4" name="Slide Number Placeholder 3"/>
+          <p:cNvSpPr>
+            <a:spLocks xmlns:a="http://schemas.openxmlformats.org/drawingml/2006/main" noGrp="1"/>
+          </p:cNvSpPr>
+          <p:nvPr>
+            <p:ph type="sldNum" idx="5"/>
+          </p:nvPr>
+        </p:nvSpPr>
+        <p:spPr/>
+        <p:txBody>
+          <a:bodyPr xmlns:a="http://schemas.openxmlformats.org/drawingml/2006/main"/>
+          <a:lstStyle xmlns:a="http://schemas.openxmlformats.org/drawingml/2006/main"/>
+          <a:p xmlns:a="http://schemas.openxmlformats.org/drawingml/2006/main"/>
+        </p:txBody>
+      </p:sp>
+    </p:spTree>
+  </p:cSld>
+  <p:clrMapOvr>
+    <a:masterClrMapping xmlns:a="http://schemas.openxmlformats.org/drawingml/2006/main"/>
+  </p:clrMapOvr>
+</p:notes>
+</file>
+
 <file path=ppt/notesSlides/notesSlide2.xml><?xml version="1.0" encoding="utf-8"?>
 <p:notes xmlns:p="http://schemas.openxmlformats.org/presentationml/2006/main">
   <p:cSld>
@@ -10983,6 +11054,3500 @@
 </p:sld>
 </file>
 
+<file path=ppt/slides/slide16.xml><?xml version="1.0" encoding="utf-8"?>
+<p:sld xmlns:p="http://schemas.openxmlformats.org/presentationml/2006/main">
+  <p:cSld>
+    <p:bg>
+      <p:bgPr>
+        <a:solidFill xmlns:a="http://schemas.openxmlformats.org/drawingml/2006/main">
+          <a:srgbClr val="FFFFFF"/>
+        </a:solidFill>
+      </p:bgPr>
+    </p:bg>
+    <p:spTree>
+      <p:nvGrpSpPr>
+        <p:cNvPr id="1" name=""/>
+        <p:cNvGrpSpPr/>
+        <p:nvPr/>
+      </p:nvGrpSpPr>
+      <p:grpSpPr>
+        <a:xfrm xmlns:a="http://schemas.openxmlformats.org/drawingml/2006/main"/>
+      </p:grpSpPr>
+      <p:sp>
+        <p:nvSpPr>
+          <p:cNvPr id="35" name="">
+            <a:extLst xmlns:a="http://schemas.openxmlformats.org/drawingml/2006/main">
+              <a:ext uri="{FF2B5EF4-FFF2-40B4-BE49-F238E27FC236}">
+                <a16:creationId xmlns:a16="http://schemas.microsoft.com/office/drawing/2014/main" id="{B99EB5BD-5285-431A-B48F-54916BF74DA5}"/>
+              </a:ext>
+            </a:extLst>
+          </p:cNvPr>
+          <p:cNvSpPr>
+            <a:spLocks xmlns:a="http://schemas.openxmlformats.org/drawingml/2006/main" noGrp="1"/>
+          </p:cNvSpPr>
+          <p:nvPr/>
+        </p:nvSpPr>
+        <p:spPr>
+          <a:xfrm xmlns:a="http://schemas.openxmlformats.org/drawingml/2006/main">
+            <a:off x="495300" y="304800"/>
+            <a:ext cx="11239500" cy="495300"/>
+          </a:xfrm>
+          <a:prstGeom xmlns:a="http://schemas.openxmlformats.org/drawingml/2006/main" prst="rect">
+            <a:avLst/>
+          </a:prstGeom>
+          <a:noFill xmlns:a="http://schemas.openxmlformats.org/drawingml/2006/main"/>
+          <a:ln xmlns:a="http://schemas.openxmlformats.org/drawingml/2006/main" w="0">
+            <a:noFill/>
+          </a:ln>
+        </p:spPr>
+        <p:txBody>
+          <a:bodyPr xmlns:a="http://schemas.openxmlformats.org/drawingml/2006/main" lIns="0" tIns="0" rIns="0" bIns="0"/>
+          <a:lstStyle xmlns:a="http://schemas.openxmlformats.org/drawingml/2006/main">
+            <a:defPPr>
+              <a:defRPr sz="2700" b="1">
+                <a:solidFill>
+                  <a:srgbClr val="243247"/>
+                </a:solidFill>
+              </a:defRPr>
+            </a:defPPr>
+            <a:lvl1pPr>
+              <a:defRPr sz="2700" b="1">
+                <a:solidFill>
+                  <a:srgbClr val="243247"/>
+                </a:solidFill>
+              </a:defRPr>
+            </a:lvl1pPr>
+            <a:lvl2pPr>
+              <a:defRPr sz="2700" b="1">
+                <a:solidFill>
+                  <a:srgbClr val="243247"/>
+                </a:solidFill>
+              </a:defRPr>
+            </a:lvl2pPr>
+            <a:lvl3pPr>
+              <a:defRPr sz="2700" b="1">
+                <a:solidFill>
+                  <a:srgbClr val="243247"/>
+                </a:solidFill>
+              </a:defRPr>
+            </a:lvl3pPr>
+            <a:lvl4pPr>
+              <a:defRPr sz="2700" b="1">
+                <a:solidFill>
+                  <a:srgbClr val="243247"/>
+                </a:solidFill>
+              </a:defRPr>
+            </a:lvl4pPr>
+            <a:lvl5pPr>
+              <a:defRPr sz="2700" b="1">
+                <a:solidFill>
+                  <a:srgbClr val="243247"/>
+                </a:solidFill>
+              </a:defRPr>
+            </a:lvl5pPr>
+            <a:lvl6pPr>
+              <a:defRPr sz="2700" b="1">
+                <a:solidFill>
+                  <a:srgbClr val="243247"/>
+                </a:solidFill>
+              </a:defRPr>
+            </a:lvl6pPr>
+            <a:lvl7pPr>
+              <a:defRPr sz="2700" b="1">
+                <a:solidFill>
+                  <a:srgbClr val="243247"/>
+                </a:solidFill>
+              </a:defRPr>
+            </a:lvl7pPr>
+            <a:lvl8pPr>
+              <a:defRPr sz="2700" b="1">
+                <a:solidFill>
+                  <a:srgbClr val="243247"/>
+                </a:solidFill>
+              </a:defRPr>
+            </a:lvl8pPr>
+            <a:lvl9pPr>
+              <a:defRPr sz="2700" b="1">
+                <a:solidFill>
+                  <a:srgbClr val="243247"/>
+                </a:solidFill>
+              </a:defRPr>
+            </a:lvl9pPr>
+          </a:lstStyle>
+          <a:p xmlns:a="http://schemas.openxmlformats.org/drawingml/2006/main">
+            <a:pPr>
+              <a:defRPr sz="2700" b="1">
+                <a:solidFill>
+                  <a:srgbClr val="243247"/>
+                </a:solidFill>
+              </a:defRPr>
+            </a:pPr>
+            <a:r>
+              <a:rPr sz="2700" b="1">
+                <a:solidFill>
+                  <a:srgbClr val="243247"/>
+                </a:solidFill>
+              </a:rPr>
+              <a:t>Les couches du système multiagents</a:t>
+            </a:r>
+          </a:p>
+        </p:txBody>
+      </p:sp>
+      <p:sp>
+        <p:nvSpPr>
+          <p:cNvPr id="2" name="">
+            <a:extLst xmlns:a="http://schemas.openxmlformats.org/drawingml/2006/main">
+              <a:ext uri="{FF2B5EF4-FFF2-40B4-BE49-F238E27FC236}">
+                <a16:creationId xmlns:a16="http://schemas.microsoft.com/office/drawing/2014/main" id="{032BA7D0-4F3A-4C0D-BECE-AC7D79FE24F8}"/>
+              </a:ext>
+            </a:extLst>
+          </p:cNvPr>
+          <p:cNvSpPr>
+            <a:spLocks xmlns:a="http://schemas.openxmlformats.org/drawingml/2006/main" noGrp="1"/>
+          </p:cNvSpPr>
+          <p:nvPr/>
+        </p:nvSpPr>
+        <p:spPr>
+          <a:xfrm xmlns:a="http://schemas.openxmlformats.org/drawingml/2006/main">
+            <a:off x="495300" y="838200"/>
+            <a:ext cx="11144250" cy="304800"/>
+          </a:xfrm>
+          <a:prstGeom xmlns:a="http://schemas.openxmlformats.org/drawingml/2006/main" prst="rect">
+            <a:avLst/>
+          </a:prstGeom>
+          <a:noFill xmlns:a="http://schemas.openxmlformats.org/drawingml/2006/main"/>
+          <a:ln xmlns:a="http://schemas.openxmlformats.org/drawingml/2006/main" w="0">
+            <a:noFill/>
+          </a:ln>
+        </p:spPr>
+        <p:txBody>
+          <a:bodyPr xmlns:a="http://schemas.openxmlformats.org/drawingml/2006/main" lIns="0" tIns="0" rIns="0" bIns="0"/>
+          <a:lstStyle xmlns:a="http://schemas.openxmlformats.org/drawingml/2006/main">
+            <a:defPPr>
+              <a:defRPr sz="1650" b="0">
+                <a:solidFill>
+                  <a:srgbClr val="586579"/>
+                </a:solidFill>
+              </a:defRPr>
+            </a:defPPr>
+            <a:lvl1pPr>
+              <a:defRPr sz="1650" b="0">
+                <a:solidFill>
+                  <a:srgbClr val="586579"/>
+                </a:solidFill>
+              </a:defRPr>
+            </a:lvl1pPr>
+            <a:lvl2pPr>
+              <a:defRPr sz="1650" b="0">
+                <a:solidFill>
+                  <a:srgbClr val="586579"/>
+                </a:solidFill>
+              </a:defRPr>
+            </a:lvl2pPr>
+            <a:lvl3pPr>
+              <a:defRPr sz="1650" b="0">
+                <a:solidFill>
+                  <a:srgbClr val="586579"/>
+                </a:solidFill>
+              </a:defRPr>
+            </a:lvl3pPr>
+            <a:lvl4pPr>
+              <a:defRPr sz="1650" b="0">
+                <a:solidFill>
+                  <a:srgbClr val="586579"/>
+                </a:solidFill>
+              </a:defRPr>
+            </a:lvl4pPr>
+            <a:lvl5pPr>
+              <a:defRPr sz="1650" b="0">
+                <a:solidFill>
+                  <a:srgbClr val="586579"/>
+                </a:solidFill>
+              </a:defRPr>
+            </a:lvl5pPr>
+            <a:lvl6pPr>
+              <a:defRPr sz="1650" b="0">
+                <a:solidFill>
+                  <a:srgbClr val="586579"/>
+                </a:solidFill>
+              </a:defRPr>
+            </a:lvl6pPr>
+            <a:lvl7pPr>
+              <a:defRPr sz="1650" b="0">
+                <a:solidFill>
+                  <a:srgbClr val="586579"/>
+                </a:solidFill>
+              </a:defRPr>
+            </a:lvl7pPr>
+            <a:lvl8pPr>
+              <a:defRPr sz="1650" b="0">
+                <a:solidFill>
+                  <a:srgbClr val="586579"/>
+                </a:solidFill>
+              </a:defRPr>
+            </a:lvl8pPr>
+            <a:lvl9pPr>
+              <a:defRPr sz="1650" b="0">
+                <a:solidFill>
+                  <a:srgbClr val="586579"/>
+                </a:solidFill>
+              </a:defRPr>
+            </a:lvl9pPr>
+          </a:lstStyle>
+          <a:p xmlns:a="http://schemas.openxmlformats.org/drawingml/2006/main">
+            <a:pPr>
+              <a:defRPr sz="1650" b="0">
+                <a:solidFill>
+                  <a:srgbClr val="586579"/>
+                </a:solidFill>
+              </a:defRPr>
+            </a:pPr>
+            <a:r>
+              <a:rPr sz="1650" b="0">
+                <a:solidFill>
+                  <a:srgbClr val="586579"/>
+                </a:solidFill>
+              </a:rPr>
+              <a:t>Du modèle au suivi du projet : des responsabilités complémentaires</a:t>
+            </a:r>
+          </a:p>
+        </p:txBody>
+      </p:sp>
+      <p:sp>
+        <p:nvSpPr>
+          <p:cNvPr id="3" name="Couche 7">
+            <a:extLst xmlns:a="http://schemas.openxmlformats.org/drawingml/2006/main">
+              <a:ext uri="{FF2B5EF4-FFF2-40B4-BE49-F238E27FC236}">
+                <a16:creationId xmlns:a16="http://schemas.microsoft.com/office/drawing/2014/main" id="{947B3CFC-3C64-49CB-9E9E-327EE79C0DA7}"/>
+              </a:ext>
+            </a:extLst>
+          </p:cNvPr>
+          <p:cNvSpPr>
+            <a:spLocks xmlns:a="http://schemas.openxmlformats.org/drawingml/2006/main" noGrp="1"/>
+          </p:cNvSpPr>
+          <p:nvPr/>
+        </p:nvSpPr>
+        <p:spPr>
+          <a:xfrm xmlns:a="http://schemas.openxmlformats.org/drawingml/2006/main">
+            <a:off x="790575" y="1304925"/>
+            <a:ext cx="4667250" cy="4667250"/>
+          </a:xfrm>
+          <a:prstGeom xmlns:a="http://schemas.openxmlformats.org/drawingml/2006/main" prst="ellipse">
+            <a:avLst/>
+          </a:prstGeom>
+          <a:solidFill xmlns:a="http://schemas.openxmlformats.org/drawingml/2006/main">
+            <a:srgbClr val="F5EAF6"/>
+          </a:solidFill>
+          <a:ln xmlns:a="http://schemas.openxmlformats.org/drawingml/2006/main" w="9525">
+            <a:solidFill>
+              <a:srgbClr val="8899AB"/>
+            </a:solidFill>
+          </a:ln>
+        </p:spPr>
+      </p:sp>
+      <p:sp>
+        <p:nvSpPr>
+          <p:cNvPr id="4" name="">
+            <a:extLst xmlns:a="http://schemas.openxmlformats.org/drawingml/2006/main">
+              <a:ext uri="{FF2B5EF4-FFF2-40B4-BE49-F238E27FC236}">
+                <a16:creationId xmlns:a16="http://schemas.microsoft.com/office/drawing/2014/main" id="{6A4174B4-4FAC-4E0E-9DD6-39437F5EB07E}"/>
+              </a:ext>
+            </a:extLst>
+          </p:cNvPr>
+          <p:cNvSpPr>
+            <a:spLocks xmlns:a="http://schemas.openxmlformats.org/drawingml/2006/main" noGrp="1"/>
+          </p:cNvSpPr>
+          <p:nvPr/>
+        </p:nvSpPr>
+        <p:spPr>
+          <a:xfrm xmlns:a="http://schemas.openxmlformats.org/drawingml/2006/main">
+            <a:off x="2914650" y="1371600"/>
+            <a:ext cx="419100" cy="238125"/>
+          </a:xfrm>
+          <a:prstGeom xmlns:a="http://schemas.openxmlformats.org/drawingml/2006/main" prst="rect">
+            <a:avLst/>
+          </a:prstGeom>
+          <a:noFill xmlns:a="http://schemas.openxmlformats.org/drawingml/2006/main"/>
+          <a:ln xmlns:a="http://schemas.openxmlformats.org/drawingml/2006/main" w="0">
+            <a:noFill/>
+          </a:ln>
+        </p:spPr>
+        <p:txBody>
+          <a:bodyPr xmlns:a="http://schemas.openxmlformats.org/drawingml/2006/main" lIns="0" tIns="0" rIns="0" bIns="0"/>
+          <a:lstStyle xmlns:a="http://schemas.openxmlformats.org/drawingml/2006/main">
+            <a:defPPr>
+              <a:defRPr sz="1425" b="1">
+                <a:solidFill>
+                  <a:srgbClr val="243247"/>
+                </a:solidFill>
+              </a:defRPr>
+            </a:defPPr>
+            <a:lvl1pPr>
+              <a:defRPr sz="1425" b="1">
+                <a:solidFill>
+                  <a:srgbClr val="243247"/>
+                </a:solidFill>
+              </a:defRPr>
+            </a:lvl1pPr>
+            <a:lvl2pPr>
+              <a:defRPr sz="1425" b="1">
+                <a:solidFill>
+                  <a:srgbClr val="243247"/>
+                </a:solidFill>
+              </a:defRPr>
+            </a:lvl2pPr>
+            <a:lvl3pPr>
+              <a:defRPr sz="1425" b="1">
+                <a:solidFill>
+                  <a:srgbClr val="243247"/>
+                </a:solidFill>
+              </a:defRPr>
+            </a:lvl3pPr>
+            <a:lvl4pPr>
+              <a:defRPr sz="1425" b="1">
+                <a:solidFill>
+                  <a:srgbClr val="243247"/>
+                </a:solidFill>
+              </a:defRPr>
+            </a:lvl4pPr>
+            <a:lvl5pPr>
+              <a:defRPr sz="1425" b="1">
+                <a:solidFill>
+                  <a:srgbClr val="243247"/>
+                </a:solidFill>
+              </a:defRPr>
+            </a:lvl5pPr>
+            <a:lvl6pPr>
+              <a:defRPr sz="1425" b="1">
+                <a:solidFill>
+                  <a:srgbClr val="243247"/>
+                </a:solidFill>
+              </a:defRPr>
+            </a:lvl6pPr>
+            <a:lvl7pPr>
+              <a:defRPr sz="1425" b="1">
+                <a:solidFill>
+                  <a:srgbClr val="243247"/>
+                </a:solidFill>
+              </a:defRPr>
+            </a:lvl7pPr>
+            <a:lvl8pPr>
+              <a:defRPr sz="1425" b="1">
+                <a:solidFill>
+                  <a:srgbClr val="243247"/>
+                </a:solidFill>
+              </a:defRPr>
+            </a:lvl8pPr>
+            <a:lvl9pPr>
+              <a:defRPr sz="1425" b="1">
+                <a:solidFill>
+                  <a:srgbClr val="243247"/>
+                </a:solidFill>
+              </a:defRPr>
+            </a:lvl9pPr>
+          </a:lstStyle>
+          <a:p xmlns:a="http://schemas.openxmlformats.org/drawingml/2006/main">
+            <a:pPr>
+              <a:defRPr sz="1425" b="1">
+                <a:solidFill>
+                  <a:srgbClr val="243247"/>
+                </a:solidFill>
+              </a:defRPr>
+            </a:pPr>
+            <a:r>
+              <a:rPr sz="1425" b="1">
+                <a:solidFill>
+                  <a:srgbClr val="243247"/>
+                </a:solidFill>
+              </a:rPr>
+              <a:t>7</a:t>
+            </a:r>
+          </a:p>
+        </p:txBody>
+      </p:sp>
+      <p:sp>
+        <p:nvSpPr>
+          <p:cNvPr id="5" name="Couche 6">
+            <a:extLst xmlns:a="http://schemas.openxmlformats.org/drawingml/2006/main">
+              <a:ext uri="{FF2B5EF4-FFF2-40B4-BE49-F238E27FC236}">
+                <a16:creationId xmlns:a16="http://schemas.microsoft.com/office/drawing/2014/main" id="{27186164-8988-4DF4-9E5E-B0743ADE2E9C}"/>
+              </a:ext>
+            </a:extLst>
+          </p:cNvPr>
+          <p:cNvSpPr>
+            <a:spLocks xmlns:a="http://schemas.openxmlformats.org/drawingml/2006/main" noGrp="1"/>
+          </p:cNvSpPr>
+          <p:nvPr/>
+        </p:nvSpPr>
+        <p:spPr>
+          <a:xfrm xmlns:a="http://schemas.openxmlformats.org/drawingml/2006/main">
+            <a:off x="1104900" y="1619250"/>
+            <a:ext cx="4038600" cy="4038600"/>
+          </a:xfrm>
+          <a:prstGeom xmlns:a="http://schemas.openxmlformats.org/drawingml/2006/main" prst="ellipse">
+            <a:avLst/>
+          </a:prstGeom>
+          <a:solidFill xmlns:a="http://schemas.openxmlformats.org/drawingml/2006/main">
+            <a:srgbClr val="E9EDF8"/>
+          </a:solidFill>
+          <a:ln xmlns:a="http://schemas.openxmlformats.org/drawingml/2006/main" w="9525">
+            <a:solidFill>
+              <a:srgbClr val="8899AB"/>
+            </a:solidFill>
+          </a:ln>
+        </p:spPr>
+      </p:sp>
+      <p:sp>
+        <p:nvSpPr>
+          <p:cNvPr id="6" name="">
+            <a:extLst xmlns:a="http://schemas.openxmlformats.org/drawingml/2006/main">
+              <a:ext uri="{FF2B5EF4-FFF2-40B4-BE49-F238E27FC236}">
+                <a16:creationId xmlns:a16="http://schemas.microsoft.com/office/drawing/2014/main" id="{46D55D04-D600-4E62-B9E8-A04C86A08F34}"/>
+              </a:ext>
+            </a:extLst>
+          </p:cNvPr>
+          <p:cNvSpPr>
+            <a:spLocks xmlns:a="http://schemas.openxmlformats.org/drawingml/2006/main" noGrp="1"/>
+          </p:cNvSpPr>
+          <p:nvPr/>
+        </p:nvSpPr>
+        <p:spPr>
+          <a:xfrm xmlns:a="http://schemas.openxmlformats.org/drawingml/2006/main">
+            <a:off x="2914650" y="1685925"/>
+            <a:ext cx="419100" cy="238125"/>
+          </a:xfrm>
+          <a:prstGeom xmlns:a="http://schemas.openxmlformats.org/drawingml/2006/main" prst="rect">
+            <a:avLst/>
+          </a:prstGeom>
+          <a:noFill xmlns:a="http://schemas.openxmlformats.org/drawingml/2006/main"/>
+          <a:ln xmlns:a="http://schemas.openxmlformats.org/drawingml/2006/main" w="0">
+            <a:noFill/>
+          </a:ln>
+        </p:spPr>
+        <p:txBody>
+          <a:bodyPr xmlns:a="http://schemas.openxmlformats.org/drawingml/2006/main" lIns="0" tIns="0" rIns="0" bIns="0"/>
+          <a:lstStyle xmlns:a="http://schemas.openxmlformats.org/drawingml/2006/main">
+            <a:defPPr>
+              <a:defRPr sz="1425" b="1">
+                <a:solidFill>
+                  <a:srgbClr val="243247"/>
+                </a:solidFill>
+              </a:defRPr>
+            </a:defPPr>
+            <a:lvl1pPr>
+              <a:defRPr sz="1425" b="1">
+                <a:solidFill>
+                  <a:srgbClr val="243247"/>
+                </a:solidFill>
+              </a:defRPr>
+            </a:lvl1pPr>
+            <a:lvl2pPr>
+              <a:defRPr sz="1425" b="1">
+                <a:solidFill>
+                  <a:srgbClr val="243247"/>
+                </a:solidFill>
+              </a:defRPr>
+            </a:lvl2pPr>
+            <a:lvl3pPr>
+              <a:defRPr sz="1425" b="1">
+                <a:solidFill>
+                  <a:srgbClr val="243247"/>
+                </a:solidFill>
+              </a:defRPr>
+            </a:lvl3pPr>
+            <a:lvl4pPr>
+              <a:defRPr sz="1425" b="1">
+                <a:solidFill>
+                  <a:srgbClr val="243247"/>
+                </a:solidFill>
+              </a:defRPr>
+            </a:lvl4pPr>
+            <a:lvl5pPr>
+              <a:defRPr sz="1425" b="1">
+                <a:solidFill>
+                  <a:srgbClr val="243247"/>
+                </a:solidFill>
+              </a:defRPr>
+            </a:lvl5pPr>
+            <a:lvl6pPr>
+              <a:defRPr sz="1425" b="1">
+                <a:solidFill>
+                  <a:srgbClr val="243247"/>
+                </a:solidFill>
+              </a:defRPr>
+            </a:lvl6pPr>
+            <a:lvl7pPr>
+              <a:defRPr sz="1425" b="1">
+                <a:solidFill>
+                  <a:srgbClr val="243247"/>
+                </a:solidFill>
+              </a:defRPr>
+            </a:lvl7pPr>
+            <a:lvl8pPr>
+              <a:defRPr sz="1425" b="1">
+                <a:solidFill>
+                  <a:srgbClr val="243247"/>
+                </a:solidFill>
+              </a:defRPr>
+            </a:lvl8pPr>
+            <a:lvl9pPr>
+              <a:defRPr sz="1425" b="1">
+                <a:solidFill>
+                  <a:srgbClr val="243247"/>
+                </a:solidFill>
+              </a:defRPr>
+            </a:lvl9pPr>
+          </a:lstStyle>
+          <a:p xmlns:a="http://schemas.openxmlformats.org/drawingml/2006/main">
+            <a:pPr>
+              <a:defRPr sz="1425" b="1">
+                <a:solidFill>
+                  <a:srgbClr val="243247"/>
+                </a:solidFill>
+              </a:defRPr>
+            </a:pPr>
+            <a:r>
+              <a:rPr sz="1425" b="1">
+                <a:solidFill>
+                  <a:srgbClr val="243247"/>
+                </a:solidFill>
+              </a:rPr>
+              <a:t>6</a:t>
+            </a:r>
+          </a:p>
+        </p:txBody>
+      </p:sp>
+      <p:sp>
+        <p:nvSpPr>
+          <p:cNvPr id="7" name="Couche 5">
+            <a:extLst xmlns:a="http://schemas.openxmlformats.org/drawingml/2006/main">
+              <a:ext uri="{FF2B5EF4-FFF2-40B4-BE49-F238E27FC236}">
+                <a16:creationId xmlns:a16="http://schemas.microsoft.com/office/drawing/2014/main" id="{FEC4C4CB-F44D-4999-BF8B-EEC32081B1F4}"/>
+              </a:ext>
+            </a:extLst>
+          </p:cNvPr>
+          <p:cNvSpPr>
+            <a:spLocks xmlns:a="http://schemas.openxmlformats.org/drawingml/2006/main" noGrp="1"/>
+          </p:cNvSpPr>
+          <p:nvPr/>
+        </p:nvSpPr>
+        <p:spPr>
+          <a:xfrm xmlns:a="http://schemas.openxmlformats.org/drawingml/2006/main">
+            <a:off x="1419225" y="1933575"/>
+            <a:ext cx="3409950" cy="3409950"/>
+          </a:xfrm>
+          <a:prstGeom xmlns:a="http://schemas.openxmlformats.org/drawingml/2006/main" prst="ellipse">
+            <a:avLst/>
+          </a:prstGeom>
+          <a:solidFill xmlns:a="http://schemas.openxmlformats.org/drawingml/2006/main">
+            <a:srgbClr val="E5F2F3"/>
+          </a:solidFill>
+          <a:ln xmlns:a="http://schemas.openxmlformats.org/drawingml/2006/main" w="9525">
+            <a:solidFill>
+              <a:srgbClr val="8899AB"/>
+            </a:solidFill>
+          </a:ln>
+        </p:spPr>
+      </p:sp>
+      <p:sp>
+        <p:nvSpPr>
+          <p:cNvPr id="8" name="">
+            <a:extLst xmlns:a="http://schemas.openxmlformats.org/drawingml/2006/main">
+              <a:ext uri="{FF2B5EF4-FFF2-40B4-BE49-F238E27FC236}">
+                <a16:creationId xmlns:a16="http://schemas.microsoft.com/office/drawing/2014/main" id="{924B1492-F049-4F0B-9102-86A962C0E352}"/>
+              </a:ext>
+            </a:extLst>
+          </p:cNvPr>
+          <p:cNvSpPr>
+            <a:spLocks xmlns:a="http://schemas.openxmlformats.org/drawingml/2006/main" noGrp="1"/>
+          </p:cNvSpPr>
+          <p:nvPr/>
+        </p:nvSpPr>
+        <p:spPr>
+          <a:xfrm xmlns:a="http://schemas.openxmlformats.org/drawingml/2006/main">
+            <a:off x="2914650" y="2000250"/>
+            <a:ext cx="419100" cy="238125"/>
+          </a:xfrm>
+          <a:prstGeom xmlns:a="http://schemas.openxmlformats.org/drawingml/2006/main" prst="rect">
+            <a:avLst/>
+          </a:prstGeom>
+          <a:noFill xmlns:a="http://schemas.openxmlformats.org/drawingml/2006/main"/>
+          <a:ln xmlns:a="http://schemas.openxmlformats.org/drawingml/2006/main" w="0">
+            <a:noFill/>
+          </a:ln>
+        </p:spPr>
+        <p:txBody>
+          <a:bodyPr xmlns:a="http://schemas.openxmlformats.org/drawingml/2006/main" lIns="0" tIns="0" rIns="0" bIns="0"/>
+          <a:lstStyle xmlns:a="http://schemas.openxmlformats.org/drawingml/2006/main">
+            <a:defPPr>
+              <a:defRPr sz="1425" b="1">
+                <a:solidFill>
+                  <a:srgbClr val="243247"/>
+                </a:solidFill>
+              </a:defRPr>
+            </a:defPPr>
+            <a:lvl1pPr>
+              <a:defRPr sz="1425" b="1">
+                <a:solidFill>
+                  <a:srgbClr val="243247"/>
+                </a:solidFill>
+              </a:defRPr>
+            </a:lvl1pPr>
+            <a:lvl2pPr>
+              <a:defRPr sz="1425" b="1">
+                <a:solidFill>
+                  <a:srgbClr val="243247"/>
+                </a:solidFill>
+              </a:defRPr>
+            </a:lvl2pPr>
+            <a:lvl3pPr>
+              <a:defRPr sz="1425" b="1">
+                <a:solidFill>
+                  <a:srgbClr val="243247"/>
+                </a:solidFill>
+              </a:defRPr>
+            </a:lvl3pPr>
+            <a:lvl4pPr>
+              <a:defRPr sz="1425" b="1">
+                <a:solidFill>
+                  <a:srgbClr val="243247"/>
+                </a:solidFill>
+              </a:defRPr>
+            </a:lvl4pPr>
+            <a:lvl5pPr>
+              <a:defRPr sz="1425" b="1">
+                <a:solidFill>
+                  <a:srgbClr val="243247"/>
+                </a:solidFill>
+              </a:defRPr>
+            </a:lvl5pPr>
+            <a:lvl6pPr>
+              <a:defRPr sz="1425" b="1">
+                <a:solidFill>
+                  <a:srgbClr val="243247"/>
+                </a:solidFill>
+              </a:defRPr>
+            </a:lvl6pPr>
+            <a:lvl7pPr>
+              <a:defRPr sz="1425" b="1">
+                <a:solidFill>
+                  <a:srgbClr val="243247"/>
+                </a:solidFill>
+              </a:defRPr>
+            </a:lvl7pPr>
+            <a:lvl8pPr>
+              <a:defRPr sz="1425" b="1">
+                <a:solidFill>
+                  <a:srgbClr val="243247"/>
+                </a:solidFill>
+              </a:defRPr>
+            </a:lvl8pPr>
+            <a:lvl9pPr>
+              <a:defRPr sz="1425" b="1">
+                <a:solidFill>
+                  <a:srgbClr val="243247"/>
+                </a:solidFill>
+              </a:defRPr>
+            </a:lvl9pPr>
+          </a:lstStyle>
+          <a:p xmlns:a="http://schemas.openxmlformats.org/drawingml/2006/main">
+            <a:pPr>
+              <a:defRPr sz="1425" b="1">
+                <a:solidFill>
+                  <a:srgbClr val="243247"/>
+                </a:solidFill>
+              </a:defRPr>
+            </a:pPr>
+            <a:r>
+              <a:rPr sz="1425" b="1">
+                <a:solidFill>
+                  <a:srgbClr val="243247"/>
+                </a:solidFill>
+              </a:rPr>
+              <a:t>5</a:t>
+            </a:r>
+          </a:p>
+        </p:txBody>
+      </p:sp>
+      <p:sp>
+        <p:nvSpPr>
+          <p:cNvPr id="9" name="Couche 4">
+            <a:extLst xmlns:a="http://schemas.openxmlformats.org/drawingml/2006/main">
+              <a:ext uri="{FF2B5EF4-FFF2-40B4-BE49-F238E27FC236}">
+                <a16:creationId xmlns:a16="http://schemas.microsoft.com/office/drawing/2014/main" id="{7FF0A213-17B5-476B-AD7E-67BDBAA81F1F}"/>
+              </a:ext>
+            </a:extLst>
+          </p:cNvPr>
+          <p:cNvSpPr>
+            <a:spLocks xmlns:a="http://schemas.openxmlformats.org/drawingml/2006/main" noGrp="1"/>
+          </p:cNvSpPr>
+          <p:nvPr/>
+        </p:nvSpPr>
+        <p:spPr>
+          <a:xfrm xmlns:a="http://schemas.openxmlformats.org/drawingml/2006/main">
+            <a:off x="1733550" y="2247900"/>
+            <a:ext cx="2781300" cy="2781300"/>
+          </a:xfrm>
+          <a:prstGeom xmlns:a="http://schemas.openxmlformats.org/drawingml/2006/main" prst="ellipse">
+            <a:avLst/>
+          </a:prstGeom>
+          <a:solidFill xmlns:a="http://schemas.openxmlformats.org/drawingml/2006/main">
+            <a:srgbClr val="E7F3EA"/>
+          </a:solidFill>
+          <a:ln xmlns:a="http://schemas.openxmlformats.org/drawingml/2006/main" w="9525">
+            <a:solidFill>
+              <a:srgbClr val="8899AB"/>
+            </a:solidFill>
+          </a:ln>
+        </p:spPr>
+      </p:sp>
+      <p:sp>
+        <p:nvSpPr>
+          <p:cNvPr id="10" name="">
+            <a:extLst xmlns:a="http://schemas.openxmlformats.org/drawingml/2006/main">
+              <a:ext uri="{FF2B5EF4-FFF2-40B4-BE49-F238E27FC236}">
+                <a16:creationId xmlns:a16="http://schemas.microsoft.com/office/drawing/2014/main" id="{DD06AD31-A8EB-4DCD-950B-4F03F20BC996}"/>
+              </a:ext>
+            </a:extLst>
+          </p:cNvPr>
+          <p:cNvSpPr>
+            <a:spLocks xmlns:a="http://schemas.openxmlformats.org/drawingml/2006/main" noGrp="1"/>
+          </p:cNvSpPr>
+          <p:nvPr/>
+        </p:nvSpPr>
+        <p:spPr>
+          <a:xfrm xmlns:a="http://schemas.openxmlformats.org/drawingml/2006/main">
+            <a:off x="2914650" y="2314575"/>
+            <a:ext cx="419100" cy="238125"/>
+          </a:xfrm>
+          <a:prstGeom xmlns:a="http://schemas.openxmlformats.org/drawingml/2006/main" prst="rect">
+            <a:avLst/>
+          </a:prstGeom>
+          <a:noFill xmlns:a="http://schemas.openxmlformats.org/drawingml/2006/main"/>
+          <a:ln xmlns:a="http://schemas.openxmlformats.org/drawingml/2006/main" w="0">
+            <a:noFill/>
+          </a:ln>
+        </p:spPr>
+        <p:txBody>
+          <a:bodyPr xmlns:a="http://schemas.openxmlformats.org/drawingml/2006/main" lIns="0" tIns="0" rIns="0" bIns="0"/>
+          <a:lstStyle xmlns:a="http://schemas.openxmlformats.org/drawingml/2006/main">
+            <a:defPPr>
+              <a:defRPr sz="1425" b="1">
+                <a:solidFill>
+                  <a:srgbClr val="243247"/>
+                </a:solidFill>
+              </a:defRPr>
+            </a:defPPr>
+            <a:lvl1pPr>
+              <a:defRPr sz="1425" b="1">
+                <a:solidFill>
+                  <a:srgbClr val="243247"/>
+                </a:solidFill>
+              </a:defRPr>
+            </a:lvl1pPr>
+            <a:lvl2pPr>
+              <a:defRPr sz="1425" b="1">
+                <a:solidFill>
+                  <a:srgbClr val="243247"/>
+                </a:solidFill>
+              </a:defRPr>
+            </a:lvl2pPr>
+            <a:lvl3pPr>
+              <a:defRPr sz="1425" b="1">
+                <a:solidFill>
+                  <a:srgbClr val="243247"/>
+                </a:solidFill>
+              </a:defRPr>
+            </a:lvl3pPr>
+            <a:lvl4pPr>
+              <a:defRPr sz="1425" b="1">
+                <a:solidFill>
+                  <a:srgbClr val="243247"/>
+                </a:solidFill>
+              </a:defRPr>
+            </a:lvl4pPr>
+            <a:lvl5pPr>
+              <a:defRPr sz="1425" b="1">
+                <a:solidFill>
+                  <a:srgbClr val="243247"/>
+                </a:solidFill>
+              </a:defRPr>
+            </a:lvl5pPr>
+            <a:lvl6pPr>
+              <a:defRPr sz="1425" b="1">
+                <a:solidFill>
+                  <a:srgbClr val="243247"/>
+                </a:solidFill>
+              </a:defRPr>
+            </a:lvl6pPr>
+            <a:lvl7pPr>
+              <a:defRPr sz="1425" b="1">
+                <a:solidFill>
+                  <a:srgbClr val="243247"/>
+                </a:solidFill>
+              </a:defRPr>
+            </a:lvl7pPr>
+            <a:lvl8pPr>
+              <a:defRPr sz="1425" b="1">
+                <a:solidFill>
+                  <a:srgbClr val="243247"/>
+                </a:solidFill>
+              </a:defRPr>
+            </a:lvl8pPr>
+            <a:lvl9pPr>
+              <a:defRPr sz="1425" b="1">
+                <a:solidFill>
+                  <a:srgbClr val="243247"/>
+                </a:solidFill>
+              </a:defRPr>
+            </a:lvl9pPr>
+          </a:lstStyle>
+          <a:p xmlns:a="http://schemas.openxmlformats.org/drawingml/2006/main">
+            <a:pPr>
+              <a:defRPr sz="1425" b="1">
+                <a:solidFill>
+                  <a:srgbClr val="243247"/>
+                </a:solidFill>
+              </a:defRPr>
+            </a:pPr>
+            <a:r>
+              <a:rPr sz="1425" b="1">
+                <a:solidFill>
+                  <a:srgbClr val="243247"/>
+                </a:solidFill>
+              </a:rPr>
+              <a:t>4</a:t>
+            </a:r>
+          </a:p>
+        </p:txBody>
+      </p:sp>
+      <p:sp>
+        <p:nvSpPr>
+          <p:cNvPr id="11" name="Couche 3">
+            <a:extLst xmlns:a="http://schemas.openxmlformats.org/drawingml/2006/main">
+              <a:ext uri="{FF2B5EF4-FFF2-40B4-BE49-F238E27FC236}">
+                <a16:creationId xmlns:a16="http://schemas.microsoft.com/office/drawing/2014/main" id="{EAD49968-3839-40B9-9F9A-F6A5B7024ACD}"/>
+              </a:ext>
+            </a:extLst>
+          </p:cNvPr>
+          <p:cNvSpPr>
+            <a:spLocks xmlns:a="http://schemas.openxmlformats.org/drawingml/2006/main" noGrp="1"/>
+          </p:cNvSpPr>
+          <p:nvPr/>
+        </p:nvSpPr>
+        <p:spPr>
+          <a:xfrm xmlns:a="http://schemas.openxmlformats.org/drawingml/2006/main">
+            <a:off x="2047875" y="2562225"/>
+            <a:ext cx="2152650" cy="2152650"/>
+          </a:xfrm>
+          <a:prstGeom xmlns:a="http://schemas.openxmlformats.org/drawingml/2006/main" prst="ellipse">
+            <a:avLst/>
+          </a:prstGeom>
+          <a:solidFill xmlns:a="http://schemas.openxmlformats.org/drawingml/2006/main">
+            <a:srgbClr val="FFF2D9"/>
+          </a:solidFill>
+          <a:ln xmlns:a="http://schemas.openxmlformats.org/drawingml/2006/main" w="9525">
+            <a:solidFill>
+              <a:srgbClr val="8899AB"/>
+            </a:solidFill>
+          </a:ln>
+        </p:spPr>
+      </p:sp>
+      <p:sp>
+        <p:nvSpPr>
+          <p:cNvPr id="12" name="">
+            <a:extLst xmlns:a="http://schemas.openxmlformats.org/drawingml/2006/main">
+              <a:ext uri="{FF2B5EF4-FFF2-40B4-BE49-F238E27FC236}">
+                <a16:creationId xmlns:a16="http://schemas.microsoft.com/office/drawing/2014/main" id="{3056DDBE-2DEF-4DA3-BDC6-22D797B515DF}"/>
+              </a:ext>
+            </a:extLst>
+          </p:cNvPr>
+          <p:cNvSpPr>
+            <a:spLocks xmlns:a="http://schemas.openxmlformats.org/drawingml/2006/main" noGrp="1"/>
+          </p:cNvSpPr>
+          <p:nvPr/>
+        </p:nvSpPr>
+        <p:spPr>
+          <a:xfrm xmlns:a="http://schemas.openxmlformats.org/drawingml/2006/main">
+            <a:off x="2914650" y="2628900"/>
+            <a:ext cx="419100" cy="238125"/>
+          </a:xfrm>
+          <a:prstGeom xmlns:a="http://schemas.openxmlformats.org/drawingml/2006/main" prst="rect">
+            <a:avLst/>
+          </a:prstGeom>
+          <a:noFill xmlns:a="http://schemas.openxmlformats.org/drawingml/2006/main"/>
+          <a:ln xmlns:a="http://schemas.openxmlformats.org/drawingml/2006/main" w="0">
+            <a:noFill/>
+          </a:ln>
+        </p:spPr>
+        <p:txBody>
+          <a:bodyPr xmlns:a="http://schemas.openxmlformats.org/drawingml/2006/main" lIns="0" tIns="0" rIns="0" bIns="0"/>
+          <a:lstStyle xmlns:a="http://schemas.openxmlformats.org/drawingml/2006/main">
+            <a:defPPr>
+              <a:defRPr sz="1425" b="1">
+                <a:solidFill>
+                  <a:srgbClr val="243247"/>
+                </a:solidFill>
+              </a:defRPr>
+            </a:defPPr>
+            <a:lvl1pPr>
+              <a:defRPr sz="1425" b="1">
+                <a:solidFill>
+                  <a:srgbClr val="243247"/>
+                </a:solidFill>
+              </a:defRPr>
+            </a:lvl1pPr>
+            <a:lvl2pPr>
+              <a:defRPr sz="1425" b="1">
+                <a:solidFill>
+                  <a:srgbClr val="243247"/>
+                </a:solidFill>
+              </a:defRPr>
+            </a:lvl2pPr>
+            <a:lvl3pPr>
+              <a:defRPr sz="1425" b="1">
+                <a:solidFill>
+                  <a:srgbClr val="243247"/>
+                </a:solidFill>
+              </a:defRPr>
+            </a:lvl3pPr>
+            <a:lvl4pPr>
+              <a:defRPr sz="1425" b="1">
+                <a:solidFill>
+                  <a:srgbClr val="243247"/>
+                </a:solidFill>
+              </a:defRPr>
+            </a:lvl4pPr>
+            <a:lvl5pPr>
+              <a:defRPr sz="1425" b="1">
+                <a:solidFill>
+                  <a:srgbClr val="243247"/>
+                </a:solidFill>
+              </a:defRPr>
+            </a:lvl5pPr>
+            <a:lvl6pPr>
+              <a:defRPr sz="1425" b="1">
+                <a:solidFill>
+                  <a:srgbClr val="243247"/>
+                </a:solidFill>
+              </a:defRPr>
+            </a:lvl6pPr>
+            <a:lvl7pPr>
+              <a:defRPr sz="1425" b="1">
+                <a:solidFill>
+                  <a:srgbClr val="243247"/>
+                </a:solidFill>
+              </a:defRPr>
+            </a:lvl7pPr>
+            <a:lvl8pPr>
+              <a:defRPr sz="1425" b="1">
+                <a:solidFill>
+                  <a:srgbClr val="243247"/>
+                </a:solidFill>
+              </a:defRPr>
+            </a:lvl8pPr>
+            <a:lvl9pPr>
+              <a:defRPr sz="1425" b="1">
+                <a:solidFill>
+                  <a:srgbClr val="243247"/>
+                </a:solidFill>
+              </a:defRPr>
+            </a:lvl9pPr>
+          </a:lstStyle>
+          <a:p xmlns:a="http://schemas.openxmlformats.org/drawingml/2006/main">
+            <a:pPr>
+              <a:defRPr sz="1425" b="1">
+                <a:solidFill>
+                  <a:srgbClr val="243247"/>
+                </a:solidFill>
+              </a:defRPr>
+            </a:pPr>
+            <a:r>
+              <a:rPr sz="1425" b="1">
+                <a:solidFill>
+                  <a:srgbClr val="243247"/>
+                </a:solidFill>
+              </a:rPr>
+              <a:t>3</a:t>
+            </a:r>
+          </a:p>
+        </p:txBody>
+      </p:sp>
+      <p:sp>
+        <p:nvSpPr>
+          <p:cNvPr id="13" name="Couche 2">
+            <a:extLst xmlns:a="http://schemas.openxmlformats.org/drawingml/2006/main">
+              <a:ext uri="{FF2B5EF4-FFF2-40B4-BE49-F238E27FC236}">
+                <a16:creationId xmlns:a16="http://schemas.microsoft.com/office/drawing/2014/main" id="{3A519492-786F-434D-A17B-B3D8AC0D0CBA}"/>
+              </a:ext>
+            </a:extLst>
+          </p:cNvPr>
+          <p:cNvSpPr>
+            <a:spLocks xmlns:a="http://schemas.openxmlformats.org/drawingml/2006/main" noGrp="1"/>
+          </p:cNvSpPr>
+          <p:nvPr/>
+        </p:nvSpPr>
+        <p:spPr>
+          <a:xfrm xmlns:a="http://schemas.openxmlformats.org/drawingml/2006/main">
+            <a:off x="2362200" y="2876550"/>
+            <a:ext cx="1524000" cy="1524000"/>
+          </a:xfrm>
+          <a:prstGeom xmlns:a="http://schemas.openxmlformats.org/drawingml/2006/main" prst="ellipse">
+            <a:avLst/>
+          </a:prstGeom>
+          <a:solidFill xmlns:a="http://schemas.openxmlformats.org/drawingml/2006/main">
+            <a:srgbClr val="E8F1FC"/>
+          </a:solidFill>
+          <a:ln xmlns:a="http://schemas.openxmlformats.org/drawingml/2006/main" w="9525">
+            <a:solidFill>
+              <a:srgbClr val="8899AB"/>
+            </a:solidFill>
+          </a:ln>
+        </p:spPr>
+      </p:sp>
+      <p:sp>
+        <p:nvSpPr>
+          <p:cNvPr id="14" name="">
+            <a:extLst xmlns:a="http://schemas.openxmlformats.org/drawingml/2006/main">
+              <a:ext uri="{FF2B5EF4-FFF2-40B4-BE49-F238E27FC236}">
+                <a16:creationId xmlns:a16="http://schemas.microsoft.com/office/drawing/2014/main" id="{ECF67B43-8128-4BF3-9AC9-447D9FB4401F}"/>
+              </a:ext>
+            </a:extLst>
+          </p:cNvPr>
+          <p:cNvSpPr>
+            <a:spLocks xmlns:a="http://schemas.openxmlformats.org/drawingml/2006/main" noGrp="1"/>
+          </p:cNvSpPr>
+          <p:nvPr/>
+        </p:nvSpPr>
+        <p:spPr>
+          <a:xfrm xmlns:a="http://schemas.openxmlformats.org/drawingml/2006/main">
+            <a:off x="2914650" y="2943225"/>
+            <a:ext cx="419100" cy="238125"/>
+          </a:xfrm>
+          <a:prstGeom xmlns:a="http://schemas.openxmlformats.org/drawingml/2006/main" prst="rect">
+            <a:avLst/>
+          </a:prstGeom>
+          <a:noFill xmlns:a="http://schemas.openxmlformats.org/drawingml/2006/main"/>
+          <a:ln xmlns:a="http://schemas.openxmlformats.org/drawingml/2006/main" w="0">
+            <a:noFill/>
+          </a:ln>
+        </p:spPr>
+        <p:txBody>
+          <a:bodyPr xmlns:a="http://schemas.openxmlformats.org/drawingml/2006/main" lIns="0" tIns="0" rIns="0" bIns="0"/>
+          <a:lstStyle xmlns:a="http://schemas.openxmlformats.org/drawingml/2006/main">
+            <a:defPPr>
+              <a:defRPr sz="1425" b="1">
+                <a:solidFill>
+                  <a:srgbClr val="243247"/>
+                </a:solidFill>
+              </a:defRPr>
+            </a:defPPr>
+            <a:lvl1pPr>
+              <a:defRPr sz="1425" b="1">
+                <a:solidFill>
+                  <a:srgbClr val="243247"/>
+                </a:solidFill>
+              </a:defRPr>
+            </a:lvl1pPr>
+            <a:lvl2pPr>
+              <a:defRPr sz="1425" b="1">
+                <a:solidFill>
+                  <a:srgbClr val="243247"/>
+                </a:solidFill>
+              </a:defRPr>
+            </a:lvl2pPr>
+            <a:lvl3pPr>
+              <a:defRPr sz="1425" b="1">
+                <a:solidFill>
+                  <a:srgbClr val="243247"/>
+                </a:solidFill>
+              </a:defRPr>
+            </a:lvl3pPr>
+            <a:lvl4pPr>
+              <a:defRPr sz="1425" b="1">
+                <a:solidFill>
+                  <a:srgbClr val="243247"/>
+                </a:solidFill>
+              </a:defRPr>
+            </a:lvl4pPr>
+            <a:lvl5pPr>
+              <a:defRPr sz="1425" b="1">
+                <a:solidFill>
+                  <a:srgbClr val="243247"/>
+                </a:solidFill>
+              </a:defRPr>
+            </a:lvl5pPr>
+            <a:lvl6pPr>
+              <a:defRPr sz="1425" b="1">
+                <a:solidFill>
+                  <a:srgbClr val="243247"/>
+                </a:solidFill>
+              </a:defRPr>
+            </a:lvl6pPr>
+            <a:lvl7pPr>
+              <a:defRPr sz="1425" b="1">
+                <a:solidFill>
+                  <a:srgbClr val="243247"/>
+                </a:solidFill>
+              </a:defRPr>
+            </a:lvl7pPr>
+            <a:lvl8pPr>
+              <a:defRPr sz="1425" b="1">
+                <a:solidFill>
+                  <a:srgbClr val="243247"/>
+                </a:solidFill>
+              </a:defRPr>
+            </a:lvl8pPr>
+            <a:lvl9pPr>
+              <a:defRPr sz="1425" b="1">
+                <a:solidFill>
+                  <a:srgbClr val="243247"/>
+                </a:solidFill>
+              </a:defRPr>
+            </a:lvl9pPr>
+          </a:lstStyle>
+          <a:p xmlns:a="http://schemas.openxmlformats.org/drawingml/2006/main">
+            <a:pPr>
+              <a:defRPr sz="1425" b="1">
+                <a:solidFill>
+                  <a:srgbClr val="243247"/>
+                </a:solidFill>
+              </a:defRPr>
+            </a:pPr>
+            <a:r>
+              <a:rPr sz="1425" b="1">
+                <a:solidFill>
+                  <a:srgbClr val="243247"/>
+                </a:solidFill>
+              </a:rPr>
+              <a:t>2</a:t>
+            </a:r>
+          </a:p>
+        </p:txBody>
+      </p:sp>
+      <p:sp>
+        <p:nvSpPr>
+          <p:cNvPr id="15" name="Couche 1">
+            <a:extLst xmlns:a="http://schemas.openxmlformats.org/drawingml/2006/main">
+              <a:ext uri="{FF2B5EF4-FFF2-40B4-BE49-F238E27FC236}">
+                <a16:creationId xmlns:a16="http://schemas.microsoft.com/office/drawing/2014/main" id="{B9FBB687-9786-47C1-A678-91DE9CF83459}"/>
+              </a:ext>
+            </a:extLst>
+          </p:cNvPr>
+          <p:cNvSpPr>
+            <a:spLocks xmlns:a="http://schemas.openxmlformats.org/drawingml/2006/main" noGrp="1"/>
+          </p:cNvSpPr>
+          <p:nvPr/>
+        </p:nvSpPr>
+        <p:spPr>
+          <a:xfrm xmlns:a="http://schemas.openxmlformats.org/drawingml/2006/main">
+            <a:off x="2676525" y="3190875"/>
+            <a:ext cx="895350" cy="895350"/>
+          </a:xfrm>
+          <a:prstGeom xmlns:a="http://schemas.openxmlformats.org/drawingml/2006/main" prst="ellipse">
+            <a:avLst/>
+          </a:prstGeom>
+          <a:solidFill xmlns:a="http://schemas.openxmlformats.org/drawingml/2006/main">
+            <a:srgbClr val="D8E9FB"/>
+          </a:solidFill>
+          <a:ln xmlns:a="http://schemas.openxmlformats.org/drawingml/2006/main" w="9525">
+            <a:solidFill>
+              <a:srgbClr val="8899AB"/>
+            </a:solidFill>
+          </a:ln>
+        </p:spPr>
+      </p:sp>
+      <p:sp>
+        <p:nvSpPr>
+          <p:cNvPr id="16" name="">
+            <a:extLst xmlns:a="http://schemas.openxmlformats.org/drawingml/2006/main">
+              <a:ext uri="{FF2B5EF4-FFF2-40B4-BE49-F238E27FC236}">
+                <a16:creationId xmlns:a16="http://schemas.microsoft.com/office/drawing/2014/main" id="{2CDB11C2-B5AE-4A1B-9993-F60DD5C62195}"/>
+              </a:ext>
+            </a:extLst>
+          </p:cNvPr>
+          <p:cNvSpPr>
+            <a:spLocks xmlns:a="http://schemas.openxmlformats.org/drawingml/2006/main" noGrp="1"/>
+          </p:cNvSpPr>
+          <p:nvPr/>
+        </p:nvSpPr>
+        <p:spPr>
+          <a:xfrm xmlns:a="http://schemas.openxmlformats.org/drawingml/2006/main">
+            <a:off x="2914650" y="3257550"/>
+            <a:ext cx="419100" cy="238125"/>
+          </a:xfrm>
+          <a:prstGeom xmlns:a="http://schemas.openxmlformats.org/drawingml/2006/main" prst="rect">
+            <a:avLst/>
+          </a:prstGeom>
+          <a:noFill xmlns:a="http://schemas.openxmlformats.org/drawingml/2006/main"/>
+          <a:ln xmlns:a="http://schemas.openxmlformats.org/drawingml/2006/main" w="0">
+            <a:noFill/>
+          </a:ln>
+        </p:spPr>
+        <p:txBody>
+          <a:bodyPr xmlns:a="http://schemas.openxmlformats.org/drawingml/2006/main" lIns="0" tIns="0" rIns="0" bIns="0"/>
+          <a:lstStyle xmlns:a="http://schemas.openxmlformats.org/drawingml/2006/main">
+            <a:defPPr>
+              <a:defRPr sz="1425" b="1">
+                <a:solidFill>
+                  <a:srgbClr val="243247"/>
+                </a:solidFill>
+              </a:defRPr>
+            </a:defPPr>
+            <a:lvl1pPr>
+              <a:defRPr sz="1425" b="1">
+                <a:solidFill>
+                  <a:srgbClr val="243247"/>
+                </a:solidFill>
+              </a:defRPr>
+            </a:lvl1pPr>
+            <a:lvl2pPr>
+              <a:defRPr sz="1425" b="1">
+                <a:solidFill>
+                  <a:srgbClr val="243247"/>
+                </a:solidFill>
+              </a:defRPr>
+            </a:lvl2pPr>
+            <a:lvl3pPr>
+              <a:defRPr sz="1425" b="1">
+                <a:solidFill>
+                  <a:srgbClr val="243247"/>
+                </a:solidFill>
+              </a:defRPr>
+            </a:lvl3pPr>
+            <a:lvl4pPr>
+              <a:defRPr sz="1425" b="1">
+                <a:solidFill>
+                  <a:srgbClr val="243247"/>
+                </a:solidFill>
+              </a:defRPr>
+            </a:lvl4pPr>
+            <a:lvl5pPr>
+              <a:defRPr sz="1425" b="1">
+                <a:solidFill>
+                  <a:srgbClr val="243247"/>
+                </a:solidFill>
+              </a:defRPr>
+            </a:lvl5pPr>
+            <a:lvl6pPr>
+              <a:defRPr sz="1425" b="1">
+                <a:solidFill>
+                  <a:srgbClr val="243247"/>
+                </a:solidFill>
+              </a:defRPr>
+            </a:lvl6pPr>
+            <a:lvl7pPr>
+              <a:defRPr sz="1425" b="1">
+                <a:solidFill>
+                  <a:srgbClr val="243247"/>
+                </a:solidFill>
+              </a:defRPr>
+            </a:lvl7pPr>
+            <a:lvl8pPr>
+              <a:defRPr sz="1425" b="1">
+                <a:solidFill>
+                  <a:srgbClr val="243247"/>
+                </a:solidFill>
+              </a:defRPr>
+            </a:lvl8pPr>
+            <a:lvl9pPr>
+              <a:defRPr sz="1425" b="1">
+                <a:solidFill>
+                  <a:srgbClr val="243247"/>
+                </a:solidFill>
+              </a:defRPr>
+            </a:lvl9pPr>
+          </a:lstStyle>
+          <a:p xmlns:a="http://schemas.openxmlformats.org/drawingml/2006/main">
+            <a:pPr>
+              <a:defRPr sz="1425" b="1">
+                <a:solidFill>
+                  <a:srgbClr val="243247"/>
+                </a:solidFill>
+              </a:defRPr>
+            </a:pPr>
+            <a:r>
+              <a:rPr sz="1425" b="1">
+                <a:solidFill>
+                  <a:srgbClr val="243247"/>
+                </a:solidFill>
+              </a:rPr>
+              <a:t>1</a:t>
+            </a:r>
+          </a:p>
+        </p:txBody>
+      </p:sp>
+      <p:sp>
+        <p:nvSpPr>
+          <p:cNvPr id="17" name="">
+            <a:extLst xmlns:a="http://schemas.openxmlformats.org/drawingml/2006/main">
+              <a:ext uri="{FF2B5EF4-FFF2-40B4-BE49-F238E27FC236}">
+                <a16:creationId xmlns:a16="http://schemas.microsoft.com/office/drawing/2014/main" id="{D723596D-C70E-429C-86C1-8FA2E3060386}"/>
+              </a:ext>
+            </a:extLst>
+          </p:cNvPr>
+          <p:cNvSpPr>
+            <a:spLocks xmlns:a="http://schemas.openxmlformats.org/drawingml/2006/main" noGrp="1"/>
+          </p:cNvSpPr>
+          <p:nvPr/>
+        </p:nvSpPr>
+        <p:spPr>
+          <a:xfrm xmlns:a="http://schemas.openxmlformats.org/drawingml/2006/main">
+            <a:off x="2771775" y="3600450"/>
+            <a:ext cx="723900" cy="238125"/>
+          </a:xfrm>
+          <a:prstGeom xmlns:a="http://schemas.openxmlformats.org/drawingml/2006/main" prst="rect">
+            <a:avLst/>
+          </a:prstGeom>
+          <a:noFill xmlns:a="http://schemas.openxmlformats.org/drawingml/2006/main"/>
+          <a:ln xmlns:a="http://schemas.openxmlformats.org/drawingml/2006/main" w="0">
+            <a:noFill/>
+          </a:ln>
+        </p:spPr>
+        <p:txBody>
+          <a:bodyPr xmlns:a="http://schemas.openxmlformats.org/drawingml/2006/main" lIns="0" tIns="0" rIns="0" bIns="0"/>
+          <a:lstStyle xmlns:a="http://schemas.openxmlformats.org/drawingml/2006/main">
+            <a:defPPr>
+              <a:defRPr sz="1425" b="1">
+                <a:solidFill>
+                  <a:srgbClr val="243247"/>
+                </a:solidFill>
+              </a:defRPr>
+            </a:defPPr>
+            <a:lvl1pPr>
+              <a:defRPr sz="1425" b="1">
+                <a:solidFill>
+                  <a:srgbClr val="243247"/>
+                </a:solidFill>
+              </a:defRPr>
+            </a:lvl1pPr>
+            <a:lvl2pPr>
+              <a:defRPr sz="1425" b="1">
+                <a:solidFill>
+                  <a:srgbClr val="243247"/>
+                </a:solidFill>
+              </a:defRPr>
+            </a:lvl2pPr>
+            <a:lvl3pPr>
+              <a:defRPr sz="1425" b="1">
+                <a:solidFill>
+                  <a:srgbClr val="243247"/>
+                </a:solidFill>
+              </a:defRPr>
+            </a:lvl3pPr>
+            <a:lvl4pPr>
+              <a:defRPr sz="1425" b="1">
+                <a:solidFill>
+                  <a:srgbClr val="243247"/>
+                </a:solidFill>
+              </a:defRPr>
+            </a:lvl4pPr>
+            <a:lvl5pPr>
+              <a:defRPr sz="1425" b="1">
+                <a:solidFill>
+                  <a:srgbClr val="243247"/>
+                </a:solidFill>
+              </a:defRPr>
+            </a:lvl5pPr>
+            <a:lvl6pPr>
+              <a:defRPr sz="1425" b="1">
+                <a:solidFill>
+                  <a:srgbClr val="243247"/>
+                </a:solidFill>
+              </a:defRPr>
+            </a:lvl6pPr>
+            <a:lvl7pPr>
+              <a:defRPr sz="1425" b="1">
+                <a:solidFill>
+                  <a:srgbClr val="243247"/>
+                </a:solidFill>
+              </a:defRPr>
+            </a:lvl7pPr>
+            <a:lvl8pPr>
+              <a:defRPr sz="1425" b="1">
+                <a:solidFill>
+                  <a:srgbClr val="243247"/>
+                </a:solidFill>
+              </a:defRPr>
+            </a:lvl8pPr>
+            <a:lvl9pPr>
+              <a:defRPr sz="1425" b="1">
+                <a:solidFill>
+                  <a:srgbClr val="243247"/>
+                </a:solidFill>
+              </a:defRPr>
+            </a:lvl9pPr>
+          </a:lstStyle>
+          <a:p xmlns:a="http://schemas.openxmlformats.org/drawingml/2006/main">
+            <a:pPr>
+              <a:defRPr sz="1425" b="1">
+                <a:solidFill>
+                  <a:srgbClr val="243247"/>
+                </a:solidFill>
+              </a:defRPr>
+            </a:pPr>
+            <a:r>
+              <a:rPr sz="1425" b="1">
+                <a:solidFill>
+                  <a:srgbClr val="243247"/>
+                </a:solidFill>
+              </a:rPr>
+              <a:t>Qwen3</a:t>
+            </a:r>
+          </a:p>
+        </p:txBody>
+      </p:sp>
+      <p:sp>
+        <p:nvSpPr>
+          <p:cNvPr id="18" name="">
+            <a:extLst xmlns:a="http://schemas.openxmlformats.org/drawingml/2006/main">
+              <a:ext uri="{FF2B5EF4-FFF2-40B4-BE49-F238E27FC236}">
+                <a16:creationId xmlns:a16="http://schemas.microsoft.com/office/drawing/2014/main" id="{851838B8-EEB1-4C86-B178-80CB96F5CCBE}"/>
+              </a:ext>
+            </a:extLst>
+          </p:cNvPr>
+          <p:cNvSpPr>
+            <a:spLocks xmlns:a="http://schemas.openxmlformats.org/drawingml/2006/main" noGrp="1"/>
+          </p:cNvSpPr>
+          <p:nvPr/>
+        </p:nvSpPr>
+        <p:spPr>
+          <a:xfrm xmlns:a="http://schemas.openxmlformats.org/drawingml/2006/main">
+            <a:off x="5953125" y="1362075"/>
+            <a:ext cx="5715000" cy="276225"/>
+          </a:xfrm>
+          <a:prstGeom xmlns:a="http://schemas.openxmlformats.org/drawingml/2006/main" prst="rect">
+            <a:avLst/>
+          </a:prstGeom>
+          <a:noFill xmlns:a="http://schemas.openxmlformats.org/drawingml/2006/main"/>
+          <a:ln xmlns:a="http://schemas.openxmlformats.org/drawingml/2006/main" w="0">
+            <a:noFill/>
+          </a:ln>
+        </p:spPr>
+        <p:txBody>
+          <a:bodyPr xmlns:a="http://schemas.openxmlformats.org/drawingml/2006/main" lIns="0" tIns="0" rIns="0" bIns="0"/>
+          <a:lstStyle xmlns:a="http://schemas.openxmlformats.org/drawingml/2006/main">
+            <a:defPPr>
+              <a:defRPr sz="1725" b="1">
+                <a:solidFill>
+                  <a:srgbClr val="243247"/>
+                </a:solidFill>
+              </a:defRPr>
+            </a:defPPr>
+            <a:lvl1pPr>
+              <a:defRPr sz="1725" b="1">
+                <a:solidFill>
+                  <a:srgbClr val="243247"/>
+                </a:solidFill>
+              </a:defRPr>
+            </a:lvl1pPr>
+            <a:lvl2pPr>
+              <a:defRPr sz="1725" b="1">
+                <a:solidFill>
+                  <a:srgbClr val="243247"/>
+                </a:solidFill>
+              </a:defRPr>
+            </a:lvl2pPr>
+            <a:lvl3pPr>
+              <a:defRPr sz="1725" b="1">
+                <a:solidFill>
+                  <a:srgbClr val="243247"/>
+                </a:solidFill>
+              </a:defRPr>
+            </a:lvl3pPr>
+            <a:lvl4pPr>
+              <a:defRPr sz="1725" b="1">
+                <a:solidFill>
+                  <a:srgbClr val="243247"/>
+                </a:solidFill>
+              </a:defRPr>
+            </a:lvl4pPr>
+            <a:lvl5pPr>
+              <a:defRPr sz="1725" b="1">
+                <a:solidFill>
+                  <a:srgbClr val="243247"/>
+                </a:solidFill>
+              </a:defRPr>
+            </a:lvl5pPr>
+            <a:lvl6pPr>
+              <a:defRPr sz="1725" b="1">
+                <a:solidFill>
+                  <a:srgbClr val="243247"/>
+                </a:solidFill>
+              </a:defRPr>
+            </a:lvl6pPr>
+            <a:lvl7pPr>
+              <a:defRPr sz="1725" b="1">
+                <a:solidFill>
+                  <a:srgbClr val="243247"/>
+                </a:solidFill>
+              </a:defRPr>
+            </a:lvl7pPr>
+            <a:lvl8pPr>
+              <a:defRPr sz="1725" b="1">
+                <a:solidFill>
+                  <a:srgbClr val="243247"/>
+                </a:solidFill>
+              </a:defRPr>
+            </a:lvl8pPr>
+            <a:lvl9pPr>
+              <a:defRPr sz="1725" b="1">
+                <a:solidFill>
+                  <a:srgbClr val="243247"/>
+                </a:solidFill>
+              </a:defRPr>
+            </a:lvl9pPr>
+          </a:lstStyle>
+          <a:p xmlns:a="http://schemas.openxmlformats.org/drawingml/2006/main">
+            <a:pPr>
+              <a:defRPr sz="1725" b="1">
+                <a:solidFill>
+                  <a:srgbClr val="243247"/>
+                </a:solidFill>
+              </a:defRPr>
+            </a:pPr>
+            <a:r>
+              <a:rPr sz="1725" b="1">
+                <a:solidFill>
+                  <a:srgbClr val="243247"/>
+                </a:solidFill>
+              </a:rPr>
+              <a:t>1  Qwen3</a:t>
+            </a:r>
+          </a:p>
+        </p:txBody>
+      </p:sp>
+      <p:sp>
+        <p:nvSpPr>
+          <p:cNvPr id="19" name="">
+            <a:extLst xmlns:a="http://schemas.openxmlformats.org/drawingml/2006/main">
+              <a:ext uri="{FF2B5EF4-FFF2-40B4-BE49-F238E27FC236}">
+                <a16:creationId xmlns:a16="http://schemas.microsoft.com/office/drawing/2014/main" id="{8ACEAAC3-5CDB-409D-9CF2-B26AA64510F9}"/>
+              </a:ext>
+            </a:extLst>
+          </p:cNvPr>
+          <p:cNvSpPr>
+            <a:spLocks xmlns:a="http://schemas.openxmlformats.org/drawingml/2006/main" noGrp="1"/>
+          </p:cNvSpPr>
+          <p:nvPr/>
+        </p:nvSpPr>
+        <p:spPr>
+          <a:xfrm xmlns:a="http://schemas.openxmlformats.org/drawingml/2006/main">
+            <a:off x="5953125" y="1657350"/>
+            <a:ext cx="5715000" cy="266700"/>
+          </a:xfrm>
+          <a:prstGeom xmlns:a="http://schemas.openxmlformats.org/drawingml/2006/main" prst="rect">
+            <a:avLst/>
+          </a:prstGeom>
+          <a:noFill xmlns:a="http://schemas.openxmlformats.org/drawingml/2006/main"/>
+          <a:ln xmlns:a="http://schemas.openxmlformats.org/drawingml/2006/main" w="0">
+            <a:noFill/>
+          </a:ln>
+        </p:spPr>
+        <p:txBody>
+          <a:bodyPr xmlns:a="http://schemas.openxmlformats.org/drawingml/2006/main" lIns="0" tIns="0" rIns="0" bIns="0"/>
+          <a:lstStyle xmlns:a="http://schemas.openxmlformats.org/drawingml/2006/main">
+            <a:defPPr>
+              <a:defRPr sz="1350" b="0">
+                <a:solidFill>
+                  <a:srgbClr val="586579"/>
+                </a:solidFill>
+              </a:defRPr>
+            </a:defPPr>
+            <a:lvl1pPr>
+              <a:defRPr sz="1350" b="0">
+                <a:solidFill>
+                  <a:srgbClr val="586579"/>
+                </a:solidFill>
+              </a:defRPr>
+            </a:lvl1pPr>
+            <a:lvl2pPr>
+              <a:defRPr sz="1350" b="0">
+                <a:solidFill>
+                  <a:srgbClr val="586579"/>
+                </a:solidFill>
+              </a:defRPr>
+            </a:lvl2pPr>
+            <a:lvl3pPr>
+              <a:defRPr sz="1350" b="0">
+                <a:solidFill>
+                  <a:srgbClr val="586579"/>
+                </a:solidFill>
+              </a:defRPr>
+            </a:lvl3pPr>
+            <a:lvl4pPr>
+              <a:defRPr sz="1350" b="0">
+                <a:solidFill>
+                  <a:srgbClr val="586579"/>
+                </a:solidFill>
+              </a:defRPr>
+            </a:lvl4pPr>
+            <a:lvl5pPr>
+              <a:defRPr sz="1350" b="0">
+                <a:solidFill>
+                  <a:srgbClr val="586579"/>
+                </a:solidFill>
+              </a:defRPr>
+            </a:lvl5pPr>
+            <a:lvl6pPr>
+              <a:defRPr sz="1350" b="0">
+                <a:solidFill>
+                  <a:srgbClr val="586579"/>
+                </a:solidFill>
+              </a:defRPr>
+            </a:lvl6pPr>
+            <a:lvl7pPr>
+              <a:defRPr sz="1350" b="0">
+                <a:solidFill>
+                  <a:srgbClr val="586579"/>
+                </a:solidFill>
+              </a:defRPr>
+            </a:lvl7pPr>
+            <a:lvl8pPr>
+              <a:defRPr sz="1350" b="0">
+                <a:solidFill>
+                  <a:srgbClr val="586579"/>
+                </a:solidFill>
+              </a:defRPr>
+            </a:lvl8pPr>
+            <a:lvl9pPr>
+              <a:defRPr sz="1350" b="0">
+                <a:solidFill>
+                  <a:srgbClr val="586579"/>
+                </a:solidFill>
+              </a:defRPr>
+            </a:lvl9pPr>
+          </a:lstStyle>
+          <a:p xmlns:a="http://schemas.openxmlformats.org/drawingml/2006/main">
+            <a:pPr>
+              <a:defRPr sz="1350" b="0">
+                <a:solidFill>
+                  <a:srgbClr val="586579"/>
+                </a:solidFill>
+              </a:defRPr>
+            </a:pPr>
+            <a:r>
+              <a:rPr sz="1350" b="0">
+                <a:solidFill>
+                  <a:srgbClr val="586579"/>
+                </a:solidFill>
+              </a:rPr>
+              <a:t>Modèle : interprète les instructions et répond.</a:t>
+            </a:r>
+          </a:p>
+        </p:txBody>
+      </p:sp>
+      <p:sp>
+        <p:nvSpPr>
+          <p:cNvPr id="20" name="">
+            <a:extLst xmlns:a="http://schemas.openxmlformats.org/drawingml/2006/main">
+              <a:ext uri="{FF2B5EF4-FFF2-40B4-BE49-F238E27FC236}">
+                <a16:creationId xmlns:a16="http://schemas.microsoft.com/office/drawing/2014/main" id="{69627857-20C9-478D-977B-ACD792DA6842}"/>
+              </a:ext>
+            </a:extLst>
+          </p:cNvPr>
+          <p:cNvSpPr>
+            <a:spLocks xmlns:a="http://schemas.openxmlformats.org/drawingml/2006/main" noGrp="1"/>
+          </p:cNvSpPr>
+          <p:nvPr/>
+        </p:nvSpPr>
+        <p:spPr>
+          <a:xfrm xmlns:a="http://schemas.openxmlformats.org/drawingml/2006/main">
+            <a:off x="5953125" y="1981200"/>
+            <a:ext cx="5715000" cy="276225"/>
+          </a:xfrm>
+          <a:prstGeom xmlns:a="http://schemas.openxmlformats.org/drawingml/2006/main" prst="rect">
+            <a:avLst/>
+          </a:prstGeom>
+          <a:noFill xmlns:a="http://schemas.openxmlformats.org/drawingml/2006/main"/>
+          <a:ln xmlns:a="http://schemas.openxmlformats.org/drawingml/2006/main" w="0">
+            <a:noFill/>
+          </a:ln>
+        </p:spPr>
+        <p:txBody>
+          <a:bodyPr xmlns:a="http://schemas.openxmlformats.org/drawingml/2006/main" lIns="0" tIns="0" rIns="0" bIns="0"/>
+          <a:lstStyle xmlns:a="http://schemas.openxmlformats.org/drawingml/2006/main">
+            <a:defPPr>
+              <a:defRPr sz="1725" b="1">
+                <a:solidFill>
+                  <a:srgbClr val="243247"/>
+                </a:solidFill>
+              </a:defRPr>
+            </a:defPPr>
+            <a:lvl1pPr>
+              <a:defRPr sz="1725" b="1">
+                <a:solidFill>
+                  <a:srgbClr val="243247"/>
+                </a:solidFill>
+              </a:defRPr>
+            </a:lvl1pPr>
+            <a:lvl2pPr>
+              <a:defRPr sz="1725" b="1">
+                <a:solidFill>
+                  <a:srgbClr val="243247"/>
+                </a:solidFill>
+              </a:defRPr>
+            </a:lvl2pPr>
+            <a:lvl3pPr>
+              <a:defRPr sz="1725" b="1">
+                <a:solidFill>
+                  <a:srgbClr val="243247"/>
+                </a:solidFill>
+              </a:defRPr>
+            </a:lvl3pPr>
+            <a:lvl4pPr>
+              <a:defRPr sz="1725" b="1">
+                <a:solidFill>
+                  <a:srgbClr val="243247"/>
+                </a:solidFill>
+              </a:defRPr>
+            </a:lvl4pPr>
+            <a:lvl5pPr>
+              <a:defRPr sz="1725" b="1">
+                <a:solidFill>
+                  <a:srgbClr val="243247"/>
+                </a:solidFill>
+              </a:defRPr>
+            </a:lvl5pPr>
+            <a:lvl6pPr>
+              <a:defRPr sz="1725" b="1">
+                <a:solidFill>
+                  <a:srgbClr val="243247"/>
+                </a:solidFill>
+              </a:defRPr>
+            </a:lvl6pPr>
+            <a:lvl7pPr>
+              <a:defRPr sz="1725" b="1">
+                <a:solidFill>
+                  <a:srgbClr val="243247"/>
+                </a:solidFill>
+              </a:defRPr>
+            </a:lvl7pPr>
+            <a:lvl8pPr>
+              <a:defRPr sz="1725" b="1">
+                <a:solidFill>
+                  <a:srgbClr val="243247"/>
+                </a:solidFill>
+              </a:defRPr>
+            </a:lvl8pPr>
+            <a:lvl9pPr>
+              <a:defRPr sz="1725" b="1">
+                <a:solidFill>
+                  <a:srgbClr val="243247"/>
+                </a:solidFill>
+              </a:defRPr>
+            </a:lvl9pPr>
+          </a:lstStyle>
+          <a:p xmlns:a="http://schemas.openxmlformats.org/drawingml/2006/main">
+            <a:pPr>
+              <a:defRPr sz="1725" b="1">
+                <a:solidFill>
+                  <a:srgbClr val="243247"/>
+                </a:solidFill>
+              </a:defRPr>
+            </a:pPr>
+            <a:r>
+              <a:rPr sz="1725" b="1">
+                <a:solidFill>
+                  <a:srgbClr val="243247"/>
+                </a:solidFill>
+              </a:rPr>
+              <a:t>2  Ollama</a:t>
+            </a:r>
+          </a:p>
+        </p:txBody>
+      </p:sp>
+      <p:sp>
+        <p:nvSpPr>
+          <p:cNvPr id="21" name="">
+            <a:extLst xmlns:a="http://schemas.openxmlformats.org/drawingml/2006/main">
+              <a:ext uri="{FF2B5EF4-FFF2-40B4-BE49-F238E27FC236}">
+                <a16:creationId xmlns:a16="http://schemas.microsoft.com/office/drawing/2014/main" id="{088519D2-DD29-4958-96EC-1E557EC361AD}"/>
+              </a:ext>
+            </a:extLst>
+          </p:cNvPr>
+          <p:cNvSpPr>
+            <a:spLocks xmlns:a="http://schemas.openxmlformats.org/drawingml/2006/main" noGrp="1"/>
+          </p:cNvSpPr>
+          <p:nvPr/>
+        </p:nvSpPr>
+        <p:spPr>
+          <a:xfrm xmlns:a="http://schemas.openxmlformats.org/drawingml/2006/main">
+            <a:off x="5953125" y="2276475"/>
+            <a:ext cx="5715000" cy="266700"/>
+          </a:xfrm>
+          <a:prstGeom xmlns:a="http://schemas.openxmlformats.org/drawingml/2006/main" prst="rect">
+            <a:avLst/>
+          </a:prstGeom>
+          <a:noFill xmlns:a="http://schemas.openxmlformats.org/drawingml/2006/main"/>
+          <a:ln xmlns:a="http://schemas.openxmlformats.org/drawingml/2006/main" w="0">
+            <a:noFill/>
+          </a:ln>
+        </p:spPr>
+        <p:txBody>
+          <a:bodyPr xmlns:a="http://schemas.openxmlformats.org/drawingml/2006/main" lIns="0" tIns="0" rIns="0" bIns="0"/>
+          <a:lstStyle xmlns:a="http://schemas.openxmlformats.org/drawingml/2006/main">
+            <a:defPPr>
+              <a:defRPr sz="1350" b="0">
+                <a:solidFill>
+                  <a:srgbClr val="586579"/>
+                </a:solidFill>
+              </a:defRPr>
+            </a:defPPr>
+            <a:lvl1pPr>
+              <a:defRPr sz="1350" b="0">
+                <a:solidFill>
+                  <a:srgbClr val="586579"/>
+                </a:solidFill>
+              </a:defRPr>
+            </a:lvl1pPr>
+            <a:lvl2pPr>
+              <a:defRPr sz="1350" b="0">
+                <a:solidFill>
+                  <a:srgbClr val="586579"/>
+                </a:solidFill>
+              </a:defRPr>
+            </a:lvl2pPr>
+            <a:lvl3pPr>
+              <a:defRPr sz="1350" b="0">
+                <a:solidFill>
+                  <a:srgbClr val="586579"/>
+                </a:solidFill>
+              </a:defRPr>
+            </a:lvl3pPr>
+            <a:lvl4pPr>
+              <a:defRPr sz="1350" b="0">
+                <a:solidFill>
+                  <a:srgbClr val="586579"/>
+                </a:solidFill>
+              </a:defRPr>
+            </a:lvl4pPr>
+            <a:lvl5pPr>
+              <a:defRPr sz="1350" b="0">
+                <a:solidFill>
+                  <a:srgbClr val="586579"/>
+                </a:solidFill>
+              </a:defRPr>
+            </a:lvl5pPr>
+            <a:lvl6pPr>
+              <a:defRPr sz="1350" b="0">
+                <a:solidFill>
+                  <a:srgbClr val="586579"/>
+                </a:solidFill>
+              </a:defRPr>
+            </a:lvl6pPr>
+            <a:lvl7pPr>
+              <a:defRPr sz="1350" b="0">
+                <a:solidFill>
+                  <a:srgbClr val="586579"/>
+                </a:solidFill>
+              </a:defRPr>
+            </a:lvl7pPr>
+            <a:lvl8pPr>
+              <a:defRPr sz="1350" b="0">
+                <a:solidFill>
+                  <a:srgbClr val="586579"/>
+                </a:solidFill>
+              </a:defRPr>
+            </a:lvl8pPr>
+            <a:lvl9pPr>
+              <a:defRPr sz="1350" b="0">
+                <a:solidFill>
+                  <a:srgbClr val="586579"/>
+                </a:solidFill>
+              </a:defRPr>
+            </a:lvl9pPr>
+          </a:lstStyle>
+          <a:p xmlns:a="http://schemas.openxmlformats.org/drawingml/2006/main">
+            <a:pPr>
+              <a:defRPr sz="1350" b="0">
+                <a:solidFill>
+                  <a:srgbClr val="586579"/>
+                </a:solidFill>
+              </a:defRPr>
+            </a:pPr>
+            <a:r>
+              <a:rPr sz="1350" b="0">
+                <a:solidFill>
+                  <a:srgbClr val="586579"/>
+                </a:solidFill>
+              </a:rPr>
+              <a:t>Moteur : exécute le modèle sur le poste.</a:t>
+            </a:r>
+          </a:p>
+        </p:txBody>
+      </p:sp>
+      <p:sp>
+        <p:nvSpPr>
+          <p:cNvPr id="22" name="">
+            <a:extLst xmlns:a="http://schemas.openxmlformats.org/drawingml/2006/main">
+              <a:ext uri="{FF2B5EF4-FFF2-40B4-BE49-F238E27FC236}">
+                <a16:creationId xmlns:a16="http://schemas.microsoft.com/office/drawing/2014/main" id="{F105E8F9-6FCE-4151-A2BF-39A5ED020E52}"/>
+              </a:ext>
+            </a:extLst>
+          </p:cNvPr>
+          <p:cNvSpPr>
+            <a:spLocks xmlns:a="http://schemas.openxmlformats.org/drawingml/2006/main" noGrp="1"/>
+          </p:cNvSpPr>
+          <p:nvPr/>
+        </p:nvSpPr>
+        <p:spPr>
+          <a:xfrm xmlns:a="http://schemas.openxmlformats.org/drawingml/2006/main">
+            <a:off x="5953125" y="2600325"/>
+            <a:ext cx="5715000" cy="276225"/>
+          </a:xfrm>
+          <a:prstGeom xmlns:a="http://schemas.openxmlformats.org/drawingml/2006/main" prst="rect">
+            <a:avLst/>
+          </a:prstGeom>
+          <a:noFill xmlns:a="http://schemas.openxmlformats.org/drawingml/2006/main"/>
+          <a:ln xmlns:a="http://schemas.openxmlformats.org/drawingml/2006/main" w="0">
+            <a:noFill/>
+          </a:ln>
+        </p:spPr>
+        <p:txBody>
+          <a:bodyPr xmlns:a="http://schemas.openxmlformats.org/drawingml/2006/main" lIns="0" tIns="0" rIns="0" bIns="0"/>
+          <a:lstStyle xmlns:a="http://schemas.openxmlformats.org/drawingml/2006/main">
+            <a:defPPr>
+              <a:defRPr sz="1725" b="1">
+                <a:solidFill>
+                  <a:srgbClr val="243247"/>
+                </a:solidFill>
+              </a:defRPr>
+            </a:defPPr>
+            <a:lvl1pPr>
+              <a:defRPr sz="1725" b="1">
+                <a:solidFill>
+                  <a:srgbClr val="243247"/>
+                </a:solidFill>
+              </a:defRPr>
+            </a:lvl1pPr>
+            <a:lvl2pPr>
+              <a:defRPr sz="1725" b="1">
+                <a:solidFill>
+                  <a:srgbClr val="243247"/>
+                </a:solidFill>
+              </a:defRPr>
+            </a:lvl2pPr>
+            <a:lvl3pPr>
+              <a:defRPr sz="1725" b="1">
+                <a:solidFill>
+                  <a:srgbClr val="243247"/>
+                </a:solidFill>
+              </a:defRPr>
+            </a:lvl3pPr>
+            <a:lvl4pPr>
+              <a:defRPr sz="1725" b="1">
+                <a:solidFill>
+                  <a:srgbClr val="243247"/>
+                </a:solidFill>
+              </a:defRPr>
+            </a:lvl4pPr>
+            <a:lvl5pPr>
+              <a:defRPr sz="1725" b="1">
+                <a:solidFill>
+                  <a:srgbClr val="243247"/>
+                </a:solidFill>
+              </a:defRPr>
+            </a:lvl5pPr>
+            <a:lvl6pPr>
+              <a:defRPr sz="1725" b="1">
+                <a:solidFill>
+                  <a:srgbClr val="243247"/>
+                </a:solidFill>
+              </a:defRPr>
+            </a:lvl6pPr>
+            <a:lvl7pPr>
+              <a:defRPr sz="1725" b="1">
+                <a:solidFill>
+                  <a:srgbClr val="243247"/>
+                </a:solidFill>
+              </a:defRPr>
+            </a:lvl7pPr>
+            <a:lvl8pPr>
+              <a:defRPr sz="1725" b="1">
+                <a:solidFill>
+                  <a:srgbClr val="243247"/>
+                </a:solidFill>
+              </a:defRPr>
+            </a:lvl8pPr>
+            <a:lvl9pPr>
+              <a:defRPr sz="1725" b="1">
+                <a:solidFill>
+                  <a:srgbClr val="243247"/>
+                </a:solidFill>
+              </a:defRPr>
+            </a:lvl9pPr>
+          </a:lstStyle>
+          <a:p xmlns:a="http://schemas.openxmlformats.org/drawingml/2006/main">
+            <a:pPr>
+              <a:defRPr sz="1725" b="1">
+                <a:solidFill>
+                  <a:srgbClr val="243247"/>
+                </a:solidFill>
+              </a:defRPr>
+            </a:pPr>
+            <a:r>
+              <a:rPr sz="1725" b="1">
+                <a:solidFill>
+                  <a:srgbClr val="243247"/>
+                </a:solidFill>
+              </a:rPr>
+              <a:t>3  CrewAI</a:t>
+            </a:r>
+          </a:p>
+        </p:txBody>
+      </p:sp>
+      <p:sp>
+        <p:nvSpPr>
+          <p:cNvPr id="23" name="">
+            <a:extLst xmlns:a="http://schemas.openxmlformats.org/drawingml/2006/main">
+              <a:ext uri="{FF2B5EF4-FFF2-40B4-BE49-F238E27FC236}">
+                <a16:creationId xmlns:a16="http://schemas.microsoft.com/office/drawing/2014/main" id="{28AD3008-C37E-4BE9-A2E9-54E38BC22D28}"/>
+              </a:ext>
+            </a:extLst>
+          </p:cNvPr>
+          <p:cNvSpPr>
+            <a:spLocks xmlns:a="http://schemas.openxmlformats.org/drawingml/2006/main" noGrp="1"/>
+          </p:cNvSpPr>
+          <p:nvPr/>
+        </p:nvSpPr>
+        <p:spPr>
+          <a:xfrm xmlns:a="http://schemas.openxmlformats.org/drawingml/2006/main">
+            <a:off x="5953125" y="2895600"/>
+            <a:ext cx="5715000" cy="266700"/>
+          </a:xfrm>
+          <a:prstGeom xmlns:a="http://schemas.openxmlformats.org/drawingml/2006/main" prst="rect">
+            <a:avLst/>
+          </a:prstGeom>
+          <a:noFill xmlns:a="http://schemas.openxmlformats.org/drawingml/2006/main"/>
+          <a:ln xmlns:a="http://schemas.openxmlformats.org/drawingml/2006/main" w="0">
+            <a:noFill/>
+          </a:ln>
+        </p:spPr>
+        <p:txBody>
+          <a:bodyPr xmlns:a="http://schemas.openxmlformats.org/drawingml/2006/main" lIns="0" tIns="0" rIns="0" bIns="0"/>
+          <a:lstStyle xmlns:a="http://schemas.openxmlformats.org/drawingml/2006/main">
+            <a:defPPr>
+              <a:defRPr sz="1350" b="0">
+                <a:solidFill>
+                  <a:srgbClr val="586579"/>
+                </a:solidFill>
+              </a:defRPr>
+            </a:defPPr>
+            <a:lvl1pPr>
+              <a:defRPr sz="1350" b="0">
+                <a:solidFill>
+                  <a:srgbClr val="586579"/>
+                </a:solidFill>
+              </a:defRPr>
+            </a:lvl1pPr>
+            <a:lvl2pPr>
+              <a:defRPr sz="1350" b="0">
+                <a:solidFill>
+                  <a:srgbClr val="586579"/>
+                </a:solidFill>
+              </a:defRPr>
+            </a:lvl2pPr>
+            <a:lvl3pPr>
+              <a:defRPr sz="1350" b="0">
+                <a:solidFill>
+                  <a:srgbClr val="586579"/>
+                </a:solidFill>
+              </a:defRPr>
+            </a:lvl3pPr>
+            <a:lvl4pPr>
+              <a:defRPr sz="1350" b="0">
+                <a:solidFill>
+                  <a:srgbClr val="586579"/>
+                </a:solidFill>
+              </a:defRPr>
+            </a:lvl4pPr>
+            <a:lvl5pPr>
+              <a:defRPr sz="1350" b="0">
+                <a:solidFill>
+                  <a:srgbClr val="586579"/>
+                </a:solidFill>
+              </a:defRPr>
+            </a:lvl5pPr>
+            <a:lvl6pPr>
+              <a:defRPr sz="1350" b="0">
+                <a:solidFill>
+                  <a:srgbClr val="586579"/>
+                </a:solidFill>
+              </a:defRPr>
+            </a:lvl6pPr>
+            <a:lvl7pPr>
+              <a:defRPr sz="1350" b="0">
+                <a:solidFill>
+                  <a:srgbClr val="586579"/>
+                </a:solidFill>
+              </a:defRPr>
+            </a:lvl7pPr>
+            <a:lvl8pPr>
+              <a:defRPr sz="1350" b="0">
+                <a:solidFill>
+                  <a:srgbClr val="586579"/>
+                </a:solidFill>
+              </a:defRPr>
+            </a:lvl8pPr>
+            <a:lvl9pPr>
+              <a:defRPr sz="1350" b="0">
+                <a:solidFill>
+                  <a:srgbClr val="586579"/>
+                </a:solidFill>
+              </a:defRPr>
+            </a:lvl9pPr>
+          </a:lstStyle>
+          <a:p xmlns:a="http://schemas.openxmlformats.org/drawingml/2006/main">
+            <a:pPr>
+              <a:defRPr sz="1350" b="0">
+                <a:solidFill>
+                  <a:srgbClr val="586579"/>
+                </a:solidFill>
+              </a:defRPr>
+            </a:pPr>
+            <a:r>
+              <a:rPr sz="1350" b="0">
+                <a:solidFill>
+                  <a:srgbClr val="586579"/>
+                </a:solidFill>
+              </a:rPr>
+              <a:t>Orchestration : quatre rôles, cinq tâches.</a:t>
+            </a:r>
+          </a:p>
+        </p:txBody>
+      </p:sp>
+      <p:sp>
+        <p:nvSpPr>
+          <p:cNvPr id="24" name="">
+            <a:extLst xmlns:a="http://schemas.openxmlformats.org/drawingml/2006/main">
+              <a:ext uri="{FF2B5EF4-FFF2-40B4-BE49-F238E27FC236}">
+                <a16:creationId xmlns:a16="http://schemas.microsoft.com/office/drawing/2014/main" id="{10D1B1DD-30B6-436D-B8FD-0CECECCB3201}"/>
+              </a:ext>
+            </a:extLst>
+          </p:cNvPr>
+          <p:cNvSpPr>
+            <a:spLocks xmlns:a="http://schemas.openxmlformats.org/drawingml/2006/main" noGrp="1"/>
+          </p:cNvSpPr>
+          <p:nvPr/>
+        </p:nvSpPr>
+        <p:spPr>
+          <a:xfrm xmlns:a="http://schemas.openxmlformats.org/drawingml/2006/main">
+            <a:off x="5953125" y="3219450"/>
+            <a:ext cx="5715000" cy="276225"/>
+          </a:xfrm>
+          <a:prstGeom xmlns:a="http://schemas.openxmlformats.org/drawingml/2006/main" prst="rect">
+            <a:avLst/>
+          </a:prstGeom>
+          <a:noFill xmlns:a="http://schemas.openxmlformats.org/drawingml/2006/main"/>
+          <a:ln xmlns:a="http://schemas.openxmlformats.org/drawingml/2006/main" w="0">
+            <a:noFill/>
+          </a:ln>
+        </p:spPr>
+        <p:txBody>
+          <a:bodyPr xmlns:a="http://schemas.openxmlformats.org/drawingml/2006/main" lIns="0" tIns="0" rIns="0" bIns="0"/>
+          <a:lstStyle xmlns:a="http://schemas.openxmlformats.org/drawingml/2006/main">
+            <a:defPPr>
+              <a:defRPr sz="1725" b="1">
+                <a:solidFill>
+                  <a:srgbClr val="243247"/>
+                </a:solidFill>
+              </a:defRPr>
+            </a:defPPr>
+            <a:lvl1pPr>
+              <a:defRPr sz="1725" b="1">
+                <a:solidFill>
+                  <a:srgbClr val="243247"/>
+                </a:solidFill>
+              </a:defRPr>
+            </a:lvl1pPr>
+            <a:lvl2pPr>
+              <a:defRPr sz="1725" b="1">
+                <a:solidFill>
+                  <a:srgbClr val="243247"/>
+                </a:solidFill>
+              </a:defRPr>
+            </a:lvl2pPr>
+            <a:lvl3pPr>
+              <a:defRPr sz="1725" b="1">
+                <a:solidFill>
+                  <a:srgbClr val="243247"/>
+                </a:solidFill>
+              </a:defRPr>
+            </a:lvl3pPr>
+            <a:lvl4pPr>
+              <a:defRPr sz="1725" b="1">
+                <a:solidFill>
+                  <a:srgbClr val="243247"/>
+                </a:solidFill>
+              </a:defRPr>
+            </a:lvl4pPr>
+            <a:lvl5pPr>
+              <a:defRPr sz="1725" b="1">
+                <a:solidFill>
+                  <a:srgbClr val="243247"/>
+                </a:solidFill>
+              </a:defRPr>
+            </a:lvl5pPr>
+            <a:lvl6pPr>
+              <a:defRPr sz="1725" b="1">
+                <a:solidFill>
+                  <a:srgbClr val="243247"/>
+                </a:solidFill>
+              </a:defRPr>
+            </a:lvl6pPr>
+            <a:lvl7pPr>
+              <a:defRPr sz="1725" b="1">
+                <a:solidFill>
+                  <a:srgbClr val="243247"/>
+                </a:solidFill>
+              </a:defRPr>
+            </a:lvl7pPr>
+            <a:lvl8pPr>
+              <a:defRPr sz="1725" b="1">
+                <a:solidFill>
+                  <a:srgbClr val="243247"/>
+                </a:solidFill>
+              </a:defRPr>
+            </a:lvl8pPr>
+            <a:lvl9pPr>
+              <a:defRPr sz="1725" b="1">
+                <a:solidFill>
+                  <a:srgbClr val="243247"/>
+                </a:solidFill>
+              </a:defRPr>
+            </a:lvl9pPr>
+          </a:lstStyle>
+          <a:p xmlns:a="http://schemas.openxmlformats.org/drawingml/2006/main">
+            <a:pPr>
+              <a:defRPr sz="1725" b="1">
+                <a:solidFill>
+                  <a:srgbClr val="243247"/>
+                </a:solidFill>
+              </a:defRPr>
+            </a:pPr>
+            <a:r>
+              <a:rPr sz="1725" b="1">
+                <a:solidFill>
+                  <a:srgbClr val="243247"/>
+                </a:solidFill>
+              </a:rPr>
+              <a:t>4  Python · CSV · SQLite</a:t>
+            </a:r>
+          </a:p>
+        </p:txBody>
+      </p:sp>
+      <p:sp>
+        <p:nvSpPr>
+          <p:cNvPr id="25" name="">
+            <a:extLst xmlns:a="http://schemas.openxmlformats.org/drawingml/2006/main">
+              <a:ext uri="{FF2B5EF4-FFF2-40B4-BE49-F238E27FC236}">
+                <a16:creationId xmlns:a16="http://schemas.microsoft.com/office/drawing/2014/main" id="{C630E919-7ED4-488B-8041-75063205DF6E}"/>
+              </a:ext>
+            </a:extLst>
+          </p:cNvPr>
+          <p:cNvSpPr>
+            <a:spLocks xmlns:a="http://schemas.openxmlformats.org/drawingml/2006/main" noGrp="1"/>
+          </p:cNvSpPr>
+          <p:nvPr/>
+        </p:nvSpPr>
+        <p:spPr>
+          <a:xfrm xmlns:a="http://schemas.openxmlformats.org/drawingml/2006/main">
+            <a:off x="5953125" y="3514725"/>
+            <a:ext cx="5715000" cy="266700"/>
+          </a:xfrm>
+          <a:prstGeom xmlns:a="http://schemas.openxmlformats.org/drawingml/2006/main" prst="rect">
+            <a:avLst/>
+          </a:prstGeom>
+          <a:noFill xmlns:a="http://schemas.openxmlformats.org/drawingml/2006/main"/>
+          <a:ln xmlns:a="http://schemas.openxmlformats.org/drawingml/2006/main" w="0">
+            <a:noFill/>
+          </a:ln>
+        </p:spPr>
+        <p:txBody>
+          <a:bodyPr xmlns:a="http://schemas.openxmlformats.org/drawingml/2006/main" lIns="0" tIns="0" rIns="0" bIns="0"/>
+          <a:lstStyle xmlns:a="http://schemas.openxmlformats.org/drawingml/2006/main">
+            <a:defPPr>
+              <a:defRPr sz="1350" b="0">
+                <a:solidFill>
+                  <a:srgbClr val="586579"/>
+                </a:solidFill>
+              </a:defRPr>
+            </a:defPPr>
+            <a:lvl1pPr>
+              <a:defRPr sz="1350" b="0">
+                <a:solidFill>
+                  <a:srgbClr val="586579"/>
+                </a:solidFill>
+              </a:defRPr>
+            </a:lvl1pPr>
+            <a:lvl2pPr>
+              <a:defRPr sz="1350" b="0">
+                <a:solidFill>
+                  <a:srgbClr val="586579"/>
+                </a:solidFill>
+              </a:defRPr>
+            </a:lvl2pPr>
+            <a:lvl3pPr>
+              <a:defRPr sz="1350" b="0">
+                <a:solidFill>
+                  <a:srgbClr val="586579"/>
+                </a:solidFill>
+              </a:defRPr>
+            </a:lvl3pPr>
+            <a:lvl4pPr>
+              <a:defRPr sz="1350" b="0">
+                <a:solidFill>
+                  <a:srgbClr val="586579"/>
+                </a:solidFill>
+              </a:defRPr>
+            </a:lvl4pPr>
+            <a:lvl5pPr>
+              <a:defRPr sz="1350" b="0">
+                <a:solidFill>
+                  <a:srgbClr val="586579"/>
+                </a:solidFill>
+              </a:defRPr>
+            </a:lvl5pPr>
+            <a:lvl6pPr>
+              <a:defRPr sz="1350" b="0">
+                <a:solidFill>
+                  <a:srgbClr val="586579"/>
+                </a:solidFill>
+              </a:defRPr>
+            </a:lvl6pPr>
+            <a:lvl7pPr>
+              <a:defRPr sz="1350" b="0">
+                <a:solidFill>
+                  <a:srgbClr val="586579"/>
+                </a:solidFill>
+              </a:defRPr>
+            </a:lvl7pPr>
+            <a:lvl8pPr>
+              <a:defRPr sz="1350" b="0">
+                <a:solidFill>
+                  <a:srgbClr val="586579"/>
+                </a:solidFill>
+              </a:defRPr>
+            </a:lvl8pPr>
+            <a:lvl9pPr>
+              <a:defRPr sz="1350" b="0">
+                <a:solidFill>
+                  <a:srgbClr val="586579"/>
+                </a:solidFill>
+              </a:defRPr>
+            </a:lvl9pPr>
+          </a:lstStyle>
+          <a:p xmlns:a="http://schemas.openxmlformats.org/drawingml/2006/main">
+            <a:pPr>
+              <a:defRPr sz="1350" b="0">
+                <a:solidFill>
+                  <a:srgbClr val="586579"/>
+                </a:solidFill>
+              </a:defRPr>
+            </a:pPr>
+            <a:r>
+              <a:rPr sz="1350" b="0">
+                <a:solidFill>
+                  <a:srgbClr val="586579"/>
+                </a:solidFill>
+              </a:rPr>
+              <a:t>Outils, données, calculs et conservation des traces.</a:t>
+            </a:r>
+          </a:p>
+        </p:txBody>
+      </p:sp>
+      <p:sp>
+        <p:nvSpPr>
+          <p:cNvPr id="26" name="">
+            <a:extLst xmlns:a="http://schemas.openxmlformats.org/drawingml/2006/main">
+              <a:ext uri="{FF2B5EF4-FFF2-40B4-BE49-F238E27FC236}">
+                <a16:creationId xmlns:a16="http://schemas.microsoft.com/office/drawing/2014/main" id="{237DDBB1-C54D-4891-9E46-53F6B9C4762A}"/>
+              </a:ext>
+            </a:extLst>
+          </p:cNvPr>
+          <p:cNvSpPr>
+            <a:spLocks xmlns:a="http://schemas.openxmlformats.org/drawingml/2006/main" noGrp="1"/>
+          </p:cNvSpPr>
+          <p:nvPr/>
+        </p:nvSpPr>
+        <p:spPr>
+          <a:xfrm xmlns:a="http://schemas.openxmlformats.org/drawingml/2006/main">
+            <a:off x="5953125" y="3838575"/>
+            <a:ext cx="5715000" cy="276225"/>
+          </a:xfrm>
+          <a:prstGeom xmlns:a="http://schemas.openxmlformats.org/drawingml/2006/main" prst="rect">
+            <a:avLst/>
+          </a:prstGeom>
+          <a:noFill xmlns:a="http://schemas.openxmlformats.org/drawingml/2006/main"/>
+          <a:ln xmlns:a="http://schemas.openxmlformats.org/drawingml/2006/main" w="0">
+            <a:noFill/>
+          </a:ln>
+        </p:spPr>
+        <p:txBody>
+          <a:bodyPr xmlns:a="http://schemas.openxmlformats.org/drawingml/2006/main" lIns="0" tIns="0" rIns="0" bIns="0"/>
+          <a:lstStyle xmlns:a="http://schemas.openxmlformats.org/drawingml/2006/main">
+            <a:defPPr>
+              <a:defRPr sz="1725" b="1">
+                <a:solidFill>
+                  <a:srgbClr val="243247"/>
+                </a:solidFill>
+              </a:defRPr>
+            </a:defPPr>
+            <a:lvl1pPr>
+              <a:defRPr sz="1725" b="1">
+                <a:solidFill>
+                  <a:srgbClr val="243247"/>
+                </a:solidFill>
+              </a:defRPr>
+            </a:lvl1pPr>
+            <a:lvl2pPr>
+              <a:defRPr sz="1725" b="1">
+                <a:solidFill>
+                  <a:srgbClr val="243247"/>
+                </a:solidFill>
+              </a:defRPr>
+            </a:lvl2pPr>
+            <a:lvl3pPr>
+              <a:defRPr sz="1725" b="1">
+                <a:solidFill>
+                  <a:srgbClr val="243247"/>
+                </a:solidFill>
+              </a:defRPr>
+            </a:lvl3pPr>
+            <a:lvl4pPr>
+              <a:defRPr sz="1725" b="1">
+                <a:solidFill>
+                  <a:srgbClr val="243247"/>
+                </a:solidFill>
+              </a:defRPr>
+            </a:lvl4pPr>
+            <a:lvl5pPr>
+              <a:defRPr sz="1725" b="1">
+                <a:solidFill>
+                  <a:srgbClr val="243247"/>
+                </a:solidFill>
+              </a:defRPr>
+            </a:lvl5pPr>
+            <a:lvl6pPr>
+              <a:defRPr sz="1725" b="1">
+                <a:solidFill>
+                  <a:srgbClr val="243247"/>
+                </a:solidFill>
+              </a:defRPr>
+            </a:lvl6pPr>
+            <a:lvl7pPr>
+              <a:defRPr sz="1725" b="1">
+                <a:solidFill>
+                  <a:srgbClr val="243247"/>
+                </a:solidFill>
+              </a:defRPr>
+            </a:lvl7pPr>
+            <a:lvl8pPr>
+              <a:defRPr sz="1725" b="1">
+                <a:solidFill>
+                  <a:srgbClr val="243247"/>
+                </a:solidFill>
+              </a:defRPr>
+            </a:lvl8pPr>
+            <a:lvl9pPr>
+              <a:defRPr sz="1725" b="1">
+                <a:solidFill>
+                  <a:srgbClr val="243247"/>
+                </a:solidFill>
+              </a:defRPr>
+            </a:lvl9pPr>
+          </a:lstStyle>
+          <a:p xmlns:a="http://schemas.openxmlformats.org/drawingml/2006/main">
+            <a:pPr>
+              <a:defRPr sz="1725" b="1">
+                <a:solidFill>
+                  <a:srgbClr val="243247"/>
+                </a:solidFill>
+              </a:defRPr>
+            </a:pPr>
+            <a:r>
+              <a:rPr sz="1725" b="1">
+                <a:solidFill>
+                  <a:srgbClr val="243247"/>
+                </a:solidFill>
+              </a:rPr>
+              <a:t>5  Streamlit · Plotly</a:t>
+            </a:r>
+          </a:p>
+        </p:txBody>
+      </p:sp>
+      <p:sp>
+        <p:nvSpPr>
+          <p:cNvPr id="27" name="">
+            <a:extLst xmlns:a="http://schemas.openxmlformats.org/drawingml/2006/main">
+              <a:ext uri="{FF2B5EF4-FFF2-40B4-BE49-F238E27FC236}">
+                <a16:creationId xmlns:a16="http://schemas.microsoft.com/office/drawing/2014/main" id="{A8797833-B061-4271-A1E7-BCE0F35193B0}"/>
+              </a:ext>
+            </a:extLst>
+          </p:cNvPr>
+          <p:cNvSpPr>
+            <a:spLocks xmlns:a="http://schemas.openxmlformats.org/drawingml/2006/main" noGrp="1"/>
+          </p:cNvSpPr>
+          <p:nvPr/>
+        </p:nvSpPr>
+        <p:spPr>
+          <a:xfrm xmlns:a="http://schemas.openxmlformats.org/drawingml/2006/main">
+            <a:off x="5953125" y="4133850"/>
+            <a:ext cx="5715000" cy="266700"/>
+          </a:xfrm>
+          <a:prstGeom xmlns:a="http://schemas.openxmlformats.org/drawingml/2006/main" prst="rect">
+            <a:avLst/>
+          </a:prstGeom>
+          <a:noFill xmlns:a="http://schemas.openxmlformats.org/drawingml/2006/main"/>
+          <a:ln xmlns:a="http://schemas.openxmlformats.org/drawingml/2006/main" w="0">
+            <a:noFill/>
+          </a:ln>
+        </p:spPr>
+        <p:txBody>
+          <a:bodyPr xmlns:a="http://schemas.openxmlformats.org/drawingml/2006/main" lIns="0" tIns="0" rIns="0" bIns="0"/>
+          <a:lstStyle xmlns:a="http://schemas.openxmlformats.org/drawingml/2006/main">
+            <a:defPPr>
+              <a:defRPr sz="1350" b="0">
+                <a:solidFill>
+                  <a:srgbClr val="586579"/>
+                </a:solidFill>
+              </a:defRPr>
+            </a:defPPr>
+            <a:lvl1pPr>
+              <a:defRPr sz="1350" b="0">
+                <a:solidFill>
+                  <a:srgbClr val="586579"/>
+                </a:solidFill>
+              </a:defRPr>
+            </a:lvl1pPr>
+            <a:lvl2pPr>
+              <a:defRPr sz="1350" b="0">
+                <a:solidFill>
+                  <a:srgbClr val="586579"/>
+                </a:solidFill>
+              </a:defRPr>
+            </a:lvl2pPr>
+            <a:lvl3pPr>
+              <a:defRPr sz="1350" b="0">
+                <a:solidFill>
+                  <a:srgbClr val="586579"/>
+                </a:solidFill>
+              </a:defRPr>
+            </a:lvl3pPr>
+            <a:lvl4pPr>
+              <a:defRPr sz="1350" b="0">
+                <a:solidFill>
+                  <a:srgbClr val="586579"/>
+                </a:solidFill>
+              </a:defRPr>
+            </a:lvl4pPr>
+            <a:lvl5pPr>
+              <a:defRPr sz="1350" b="0">
+                <a:solidFill>
+                  <a:srgbClr val="586579"/>
+                </a:solidFill>
+              </a:defRPr>
+            </a:lvl5pPr>
+            <a:lvl6pPr>
+              <a:defRPr sz="1350" b="0">
+                <a:solidFill>
+                  <a:srgbClr val="586579"/>
+                </a:solidFill>
+              </a:defRPr>
+            </a:lvl6pPr>
+            <a:lvl7pPr>
+              <a:defRPr sz="1350" b="0">
+                <a:solidFill>
+                  <a:srgbClr val="586579"/>
+                </a:solidFill>
+              </a:defRPr>
+            </a:lvl7pPr>
+            <a:lvl8pPr>
+              <a:defRPr sz="1350" b="0">
+                <a:solidFill>
+                  <a:srgbClr val="586579"/>
+                </a:solidFill>
+              </a:defRPr>
+            </a:lvl8pPr>
+            <a:lvl9pPr>
+              <a:defRPr sz="1350" b="0">
+                <a:solidFill>
+                  <a:srgbClr val="586579"/>
+                </a:solidFill>
+              </a:defRPr>
+            </a:lvl9pPr>
+          </a:lstStyle>
+          <a:p xmlns:a="http://schemas.openxmlformats.org/drawingml/2006/main">
+            <a:pPr>
+              <a:defRPr sz="1350" b="0">
+                <a:solidFill>
+                  <a:srgbClr val="586579"/>
+                </a:solidFill>
+              </a:defRPr>
+            </a:pPr>
+            <a:r>
+              <a:rPr sz="1350" b="0">
+                <a:solidFill>
+                  <a:srgbClr val="586579"/>
+                </a:solidFill>
+              </a:rPr>
+              <a:t>Interface, consultation et graphiques interactifs.</a:t>
+            </a:r>
+          </a:p>
+        </p:txBody>
+      </p:sp>
+      <p:sp>
+        <p:nvSpPr>
+          <p:cNvPr id="28" name="">
+            <a:extLst xmlns:a="http://schemas.openxmlformats.org/drawingml/2006/main">
+              <a:ext uri="{FF2B5EF4-FFF2-40B4-BE49-F238E27FC236}">
+                <a16:creationId xmlns:a16="http://schemas.microsoft.com/office/drawing/2014/main" id="{1F43E7CB-8075-485F-98E7-B7787DC34CFE}"/>
+              </a:ext>
+            </a:extLst>
+          </p:cNvPr>
+          <p:cNvSpPr>
+            <a:spLocks xmlns:a="http://schemas.openxmlformats.org/drawingml/2006/main" noGrp="1"/>
+          </p:cNvSpPr>
+          <p:nvPr/>
+        </p:nvSpPr>
+        <p:spPr>
+          <a:xfrm xmlns:a="http://schemas.openxmlformats.org/drawingml/2006/main">
+            <a:off x="5953125" y="4457700"/>
+            <a:ext cx="5715000" cy="276225"/>
+          </a:xfrm>
+          <a:prstGeom xmlns:a="http://schemas.openxmlformats.org/drawingml/2006/main" prst="rect">
+            <a:avLst/>
+          </a:prstGeom>
+          <a:noFill xmlns:a="http://schemas.openxmlformats.org/drawingml/2006/main"/>
+          <a:ln xmlns:a="http://schemas.openxmlformats.org/drawingml/2006/main" w="0">
+            <a:noFill/>
+          </a:ln>
+        </p:spPr>
+        <p:txBody>
+          <a:bodyPr xmlns:a="http://schemas.openxmlformats.org/drawingml/2006/main" lIns="0" tIns="0" rIns="0" bIns="0"/>
+          <a:lstStyle xmlns:a="http://schemas.openxmlformats.org/drawingml/2006/main">
+            <a:defPPr>
+              <a:defRPr sz="1725" b="1">
+                <a:solidFill>
+                  <a:srgbClr val="243247"/>
+                </a:solidFill>
+              </a:defRPr>
+            </a:defPPr>
+            <a:lvl1pPr>
+              <a:defRPr sz="1725" b="1">
+                <a:solidFill>
+                  <a:srgbClr val="243247"/>
+                </a:solidFill>
+              </a:defRPr>
+            </a:lvl1pPr>
+            <a:lvl2pPr>
+              <a:defRPr sz="1725" b="1">
+                <a:solidFill>
+                  <a:srgbClr val="243247"/>
+                </a:solidFill>
+              </a:defRPr>
+            </a:lvl2pPr>
+            <a:lvl3pPr>
+              <a:defRPr sz="1725" b="1">
+                <a:solidFill>
+                  <a:srgbClr val="243247"/>
+                </a:solidFill>
+              </a:defRPr>
+            </a:lvl3pPr>
+            <a:lvl4pPr>
+              <a:defRPr sz="1725" b="1">
+                <a:solidFill>
+                  <a:srgbClr val="243247"/>
+                </a:solidFill>
+              </a:defRPr>
+            </a:lvl4pPr>
+            <a:lvl5pPr>
+              <a:defRPr sz="1725" b="1">
+                <a:solidFill>
+                  <a:srgbClr val="243247"/>
+                </a:solidFill>
+              </a:defRPr>
+            </a:lvl5pPr>
+            <a:lvl6pPr>
+              <a:defRPr sz="1725" b="1">
+                <a:solidFill>
+                  <a:srgbClr val="243247"/>
+                </a:solidFill>
+              </a:defRPr>
+            </a:lvl6pPr>
+            <a:lvl7pPr>
+              <a:defRPr sz="1725" b="1">
+                <a:solidFill>
+                  <a:srgbClr val="243247"/>
+                </a:solidFill>
+              </a:defRPr>
+            </a:lvl7pPr>
+            <a:lvl8pPr>
+              <a:defRPr sz="1725" b="1">
+                <a:solidFill>
+                  <a:srgbClr val="243247"/>
+                </a:solidFill>
+              </a:defRPr>
+            </a:lvl8pPr>
+            <a:lvl9pPr>
+              <a:defRPr sz="1725" b="1">
+                <a:solidFill>
+                  <a:srgbClr val="243247"/>
+                </a:solidFill>
+              </a:defRPr>
+            </a:lvl9pPr>
+          </a:lstStyle>
+          <a:p xmlns:a="http://schemas.openxmlformats.org/drawingml/2006/main">
+            <a:pPr>
+              <a:defRPr sz="1725" b="1">
+                <a:solidFill>
+                  <a:srgbClr val="243247"/>
+                </a:solidFill>
+              </a:defRPr>
+            </a:pPr>
+            <a:r>
+              <a:rPr sz="1725" b="1">
+                <a:solidFill>
+                  <a:srgbClr val="243247"/>
+                </a:solidFill>
+              </a:rPr>
+              <a:t>6  AgentOps</a:t>
+            </a:r>
+          </a:p>
+        </p:txBody>
+      </p:sp>
+      <p:sp>
+        <p:nvSpPr>
+          <p:cNvPr id="29" name="">
+            <a:extLst xmlns:a="http://schemas.openxmlformats.org/drawingml/2006/main">
+              <a:ext uri="{FF2B5EF4-FFF2-40B4-BE49-F238E27FC236}">
+                <a16:creationId xmlns:a16="http://schemas.microsoft.com/office/drawing/2014/main" id="{5A2E62F8-7508-4CB2-B900-967714F18DEB}"/>
+              </a:ext>
+            </a:extLst>
+          </p:cNvPr>
+          <p:cNvSpPr>
+            <a:spLocks xmlns:a="http://schemas.openxmlformats.org/drawingml/2006/main" noGrp="1"/>
+          </p:cNvSpPr>
+          <p:nvPr/>
+        </p:nvSpPr>
+        <p:spPr>
+          <a:xfrm xmlns:a="http://schemas.openxmlformats.org/drawingml/2006/main">
+            <a:off x="5953125" y="4752975"/>
+            <a:ext cx="5715000" cy="266700"/>
+          </a:xfrm>
+          <a:prstGeom xmlns:a="http://schemas.openxmlformats.org/drawingml/2006/main" prst="rect">
+            <a:avLst/>
+          </a:prstGeom>
+          <a:noFill xmlns:a="http://schemas.openxmlformats.org/drawingml/2006/main"/>
+          <a:ln xmlns:a="http://schemas.openxmlformats.org/drawingml/2006/main" w="0">
+            <a:noFill/>
+          </a:ln>
+        </p:spPr>
+        <p:txBody>
+          <a:bodyPr xmlns:a="http://schemas.openxmlformats.org/drawingml/2006/main" lIns="0" tIns="0" rIns="0" bIns="0"/>
+          <a:lstStyle xmlns:a="http://schemas.openxmlformats.org/drawingml/2006/main">
+            <a:defPPr>
+              <a:defRPr sz="1350" b="0">
+                <a:solidFill>
+                  <a:srgbClr val="586579"/>
+                </a:solidFill>
+              </a:defRPr>
+            </a:defPPr>
+            <a:lvl1pPr>
+              <a:defRPr sz="1350" b="0">
+                <a:solidFill>
+                  <a:srgbClr val="586579"/>
+                </a:solidFill>
+              </a:defRPr>
+            </a:lvl1pPr>
+            <a:lvl2pPr>
+              <a:defRPr sz="1350" b="0">
+                <a:solidFill>
+                  <a:srgbClr val="586579"/>
+                </a:solidFill>
+              </a:defRPr>
+            </a:lvl2pPr>
+            <a:lvl3pPr>
+              <a:defRPr sz="1350" b="0">
+                <a:solidFill>
+                  <a:srgbClr val="586579"/>
+                </a:solidFill>
+              </a:defRPr>
+            </a:lvl3pPr>
+            <a:lvl4pPr>
+              <a:defRPr sz="1350" b="0">
+                <a:solidFill>
+                  <a:srgbClr val="586579"/>
+                </a:solidFill>
+              </a:defRPr>
+            </a:lvl4pPr>
+            <a:lvl5pPr>
+              <a:defRPr sz="1350" b="0">
+                <a:solidFill>
+                  <a:srgbClr val="586579"/>
+                </a:solidFill>
+              </a:defRPr>
+            </a:lvl5pPr>
+            <a:lvl6pPr>
+              <a:defRPr sz="1350" b="0">
+                <a:solidFill>
+                  <a:srgbClr val="586579"/>
+                </a:solidFill>
+              </a:defRPr>
+            </a:lvl6pPr>
+            <a:lvl7pPr>
+              <a:defRPr sz="1350" b="0">
+                <a:solidFill>
+                  <a:srgbClr val="586579"/>
+                </a:solidFill>
+              </a:defRPr>
+            </a:lvl7pPr>
+            <a:lvl8pPr>
+              <a:defRPr sz="1350" b="0">
+                <a:solidFill>
+                  <a:srgbClr val="586579"/>
+                </a:solidFill>
+              </a:defRPr>
+            </a:lvl8pPr>
+            <a:lvl9pPr>
+              <a:defRPr sz="1350" b="0">
+                <a:solidFill>
+                  <a:srgbClr val="586579"/>
+                </a:solidFill>
+              </a:defRPr>
+            </a:lvl9pPr>
+          </a:lstStyle>
+          <a:p xmlns:a="http://schemas.openxmlformats.org/drawingml/2006/main">
+            <a:pPr>
+              <a:defRPr sz="1350" b="0">
+                <a:solidFill>
+                  <a:srgbClr val="586579"/>
+                </a:solidFill>
+              </a:defRPr>
+            </a:pPr>
+            <a:r>
+              <a:rPr sz="1350" b="0">
+                <a:solidFill>
+                  <a:srgbClr val="586579"/>
+                </a:solidFill>
+              </a:rPr>
+              <a:t>Résumé technique externe, après exécution.</a:t>
+            </a:r>
+          </a:p>
+        </p:txBody>
+      </p:sp>
+      <p:sp>
+        <p:nvSpPr>
+          <p:cNvPr id="30" name="">
+            <a:extLst xmlns:a="http://schemas.openxmlformats.org/drawingml/2006/main">
+              <a:ext uri="{FF2B5EF4-FFF2-40B4-BE49-F238E27FC236}">
+                <a16:creationId xmlns:a16="http://schemas.microsoft.com/office/drawing/2014/main" id="{8ABBA6B7-7510-4994-BE38-3DBB3852394A}"/>
+              </a:ext>
+            </a:extLst>
+          </p:cNvPr>
+          <p:cNvSpPr>
+            <a:spLocks xmlns:a="http://schemas.openxmlformats.org/drawingml/2006/main" noGrp="1"/>
+          </p:cNvSpPr>
+          <p:nvPr/>
+        </p:nvSpPr>
+        <p:spPr>
+          <a:xfrm xmlns:a="http://schemas.openxmlformats.org/drawingml/2006/main">
+            <a:off x="5953125" y="5076825"/>
+            <a:ext cx="5715000" cy="276225"/>
+          </a:xfrm>
+          <a:prstGeom xmlns:a="http://schemas.openxmlformats.org/drawingml/2006/main" prst="rect">
+            <a:avLst/>
+          </a:prstGeom>
+          <a:noFill xmlns:a="http://schemas.openxmlformats.org/drawingml/2006/main"/>
+          <a:ln xmlns:a="http://schemas.openxmlformats.org/drawingml/2006/main" w="0">
+            <a:noFill/>
+          </a:ln>
+        </p:spPr>
+        <p:txBody>
+          <a:bodyPr xmlns:a="http://schemas.openxmlformats.org/drawingml/2006/main" lIns="0" tIns="0" rIns="0" bIns="0"/>
+          <a:lstStyle xmlns:a="http://schemas.openxmlformats.org/drawingml/2006/main">
+            <a:defPPr>
+              <a:defRPr sz="1725" b="1">
+                <a:solidFill>
+                  <a:srgbClr val="243247"/>
+                </a:solidFill>
+              </a:defRPr>
+            </a:defPPr>
+            <a:lvl1pPr>
+              <a:defRPr sz="1725" b="1">
+                <a:solidFill>
+                  <a:srgbClr val="243247"/>
+                </a:solidFill>
+              </a:defRPr>
+            </a:lvl1pPr>
+            <a:lvl2pPr>
+              <a:defRPr sz="1725" b="1">
+                <a:solidFill>
+                  <a:srgbClr val="243247"/>
+                </a:solidFill>
+              </a:defRPr>
+            </a:lvl2pPr>
+            <a:lvl3pPr>
+              <a:defRPr sz="1725" b="1">
+                <a:solidFill>
+                  <a:srgbClr val="243247"/>
+                </a:solidFill>
+              </a:defRPr>
+            </a:lvl3pPr>
+            <a:lvl4pPr>
+              <a:defRPr sz="1725" b="1">
+                <a:solidFill>
+                  <a:srgbClr val="243247"/>
+                </a:solidFill>
+              </a:defRPr>
+            </a:lvl4pPr>
+            <a:lvl5pPr>
+              <a:defRPr sz="1725" b="1">
+                <a:solidFill>
+                  <a:srgbClr val="243247"/>
+                </a:solidFill>
+              </a:defRPr>
+            </a:lvl5pPr>
+            <a:lvl6pPr>
+              <a:defRPr sz="1725" b="1">
+                <a:solidFill>
+                  <a:srgbClr val="243247"/>
+                </a:solidFill>
+              </a:defRPr>
+            </a:lvl6pPr>
+            <a:lvl7pPr>
+              <a:defRPr sz="1725" b="1">
+                <a:solidFill>
+                  <a:srgbClr val="243247"/>
+                </a:solidFill>
+              </a:defRPr>
+            </a:lvl7pPr>
+            <a:lvl8pPr>
+              <a:defRPr sz="1725" b="1">
+                <a:solidFill>
+                  <a:srgbClr val="243247"/>
+                </a:solidFill>
+              </a:defRPr>
+            </a:lvl8pPr>
+            <a:lvl9pPr>
+              <a:defRPr sz="1725" b="1">
+                <a:solidFill>
+                  <a:srgbClr val="243247"/>
+                </a:solidFill>
+              </a:defRPr>
+            </a:lvl9pPr>
+          </a:lstStyle>
+          <a:p xmlns:a="http://schemas.openxmlformats.org/drawingml/2006/main">
+            <a:pPr>
+              <a:defRPr sz="1725" b="1">
+                <a:solidFill>
+                  <a:srgbClr val="243247"/>
+                </a:solidFill>
+              </a:defRPr>
+            </a:pPr>
+            <a:r>
+              <a:rPr sz="1725" b="1">
+                <a:solidFill>
+                  <a:srgbClr val="243247"/>
+                </a:solidFill>
+              </a:rPr>
+              <a:t>7  Asana — facultatif</a:t>
+            </a:r>
+          </a:p>
+        </p:txBody>
+      </p:sp>
+      <p:sp>
+        <p:nvSpPr>
+          <p:cNvPr id="31" name="">
+            <a:extLst xmlns:a="http://schemas.openxmlformats.org/drawingml/2006/main">
+              <a:ext uri="{FF2B5EF4-FFF2-40B4-BE49-F238E27FC236}">
+                <a16:creationId xmlns:a16="http://schemas.microsoft.com/office/drawing/2014/main" id="{10F0C059-085B-41CB-B55E-9BF751039099}"/>
+              </a:ext>
+            </a:extLst>
+          </p:cNvPr>
+          <p:cNvSpPr>
+            <a:spLocks xmlns:a="http://schemas.openxmlformats.org/drawingml/2006/main" noGrp="1"/>
+          </p:cNvSpPr>
+          <p:nvPr/>
+        </p:nvSpPr>
+        <p:spPr>
+          <a:xfrm xmlns:a="http://schemas.openxmlformats.org/drawingml/2006/main">
+            <a:off x="5953125" y="5372100"/>
+            <a:ext cx="5715000" cy="266700"/>
+          </a:xfrm>
+          <a:prstGeom xmlns:a="http://schemas.openxmlformats.org/drawingml/2006/main" prst="rect">
+            <a:avLst/>
+          </a:prstGeom>
+          <a:noFill xmlns:a="http://schemas.openxmlformats.org/drawingml/2006/main"/>
+          <a:ln xmlns:a="http://schemas.openxmlformats.org/drawingml/2006/main" w="0">
+            <a:noFill/>
+          </a:ln>
+        </p:spPr>
+        <p:txBody>
+          <a:bodyPr xmlns:a="http://schemas.openxmlformats.org/drawingml/2006/main" lIns="0" tIns="0" rIns="0" bIns="0"/>
+          <a:lstStyle xmlns:a="http://schemas.openxmlformats.org/drawingml/2006/main">
+            <a:defPPr>
+              <a:defRPr sz="1350" b="0">
+                <a:solidFill>
+                  <a:srgbClr val="586579"/>
+                </a:solidFill>
+              </a:defRPr>
+            </a:defPPr>
+            <a:lvl1pPr>
+              <a:defRPr sz="1350" b="0">
+                <a:solidFill>
+                  <a:srgbClr val="586579"/>
+                </a:solidFill>
+              </a:defRPr>
+            </a:lvl1pPr>
+            <a:lvl2pPr>
+              <a:defRPr sz="1350" b="0">
+                <a:solidFill>
+                  <a:srgbClr val="586579"/>
+                </a:solidFill>
+              </a:defRPr>
+            </a:lvl2pPr>
+            <a:lvl3pPr>
+              <a:defRPr sz="1350" b="0">
+                <a:solidFill>
+                  <a:srgbClr val="586579"/>
+                </a:solidFill>
+              </a:defRPr>
+            </a:lvl3pPr>
+            <a:lvl4pPr>
+              <a:defRPr sz="1350" b="0">
+                <a:solidFill>
+                  <a:srgbClr val="586579"/>
+                </a:solidFill>
+              </a:defRPr>
+            </a:lvl4pPr>
+            <a:lvl5pPr>
+              <a:defRPr sz="1350" b="0">
+                <a:solidFill>
+                  <a:srgbClr val="586579"/>
+                </a:solidFill>
+              </a:defRPr>
+            </a:lvl5pPr>
+            <a:lvl6pPr>
+              <a:defRPr sz="1350" b="0">
+                <a:solidFill>
+                  <a:srgbClr val="586579"/>
+                </a:solidFill>
+              </a:defRPr>
+            </a:lvl6pPr>
+            <a:lvl7pPr>
+              <a:defRPr sz="1350" b="0">
+                <a:solidFill>
+                  <a:srgbClr val="586579"/>
+                </a:solidFill>
+              </a:defRPr>
+            </a:lvl7pPr>
+            <a:lvl8pPr>
+              <a:defRPr sz="1350" b="0">
+                <a:solidFill>
+                  <a:srgbClr val="586579"/>
+                </a:solidFill>
+              </a:defRPr>
+            </a:lvl8pPr>
+            <a:lvl9pPr>
+              <a:defRPr sz="1350" b="0">
+                <a:solidFill>
+                  <a:srgbClr val="586579"/>
+                </a:solidFill>
+              </a:defRPr>
+            </a:lvl9pPr>
+          </a:lstStyle>
+          <a:p xmlns:a="http://schemas.openxmlformats.org/drawingml/2006/main">
+            <a:pPr>
+              <a:defRPr sz="1350" b="0">
+                <a:solidFill>
+                  <a:srgbClr val="586579"/>
+                </a:solidFill>
+              </a:defRPr>
+            </a:pPr>
+            <a:r>
+              <a:rPr sz="1350" b="0">
+                <a:solidFill>
+                  <a:srgbClr val="586579"/>
+                </a:solidFill>
+              </a:rPr>
+              <a:t>Gestion des tâches humaines ; non intégré au TP.</a:t>
+            </a:r>
+          </a:p>
+        </p:txBody>
+      </p:sp>
+      <p:sp>
+        <p:nvSpPr>
+          <p:cNvPr id="32" name="">
+            <a:extLst xmlns:a="http://schemas.openxmlformats.org/drawingml/2006/main">
+              <a:ext uri="{FF2B5EF4-FFF2-40B4-BE49-F238E27FC236}">
+                <a16:creationId xmlns:a16="http://schemas.microsoft.com/office/drawing/2014/main" id="{50697344-D7F5-4177-9F22-4BD2459E158A}"/>
+              </a:ext>
+            </a:extLst>
+          </p:cNvPr>
+          <p:cNvSpPr>
+            <a:spLocks xmlns:a="http://schemas.openxmlformats.org/drawingml/2006/main" noGrp="1"/>
+          </p:cNvSpPr>
+          <p:nvPr/>
+        </p:nvSpPr>
+        <p:spPr>
+          <a:xfrm xmlns:a="http://schemas.openxmlformats.org/drawingml/2006/main">
+            <a:off x="495300" y="6115050"/>
+            <a:ext cx="11049000" cy="266700"/>
+          </a:xfrm>
+          <a:prstGeom xmlns:a="http://schemas.openxmlformats.org/drawingml/2006/main" prst="rect">
+            <a:avLst/>
+          </a:prstGeom>
+          <a:noFill xmlns:a="http://schemas.openxmlformats.org/drawingml/2006/main"/>
+          <a:ln xmlns:a="http://schemas.openxmlformats.org/drawingml/2006/main" w="0">
+            <a:noFill/>
+          </a:ln>
+        </p:spPr>
+        <p:txBody>
+          <a:bodyPr xmlns:a="http://schemas.openxmlformats.org/drawingml/2006/main" lIns="0" tIns="0" rIns="0" bIns="0"/>
+          <a:lstStyle xmlns:a="http://schemas.openxmlformats.org/drawingml/2006/main">
+            <a:defPPr>
+              <a:defRPr sz="1350" b="0">
+                <a:solidFill>
+                  <a:srgbClr val="586579"/>
+                </a:solidFill>
+              </a:defRPr>
+            </a:defPPr>
+            <a:lvl1pPr>
+              <a:defRPr sz="1350" b="0">
+                <a:solidFill>
+                  <a:srgbClr val="586579"/>
+                </a:solidFill>
+              </a:defRPr>
+            </a:lvl1pPr>
+            <a:lvl2pPr>
+              <a:defRPr sz="1350" b="0">
+                <a:solidFill>
+                  <a:srgbClr val="586579"/>
+                </a:solidFill>
+              </a:defRPr>
+            </a:lvl2pPr>
+            <a:lvl3pPr>
+              <a:defRPr sz="1350" b="0">
+                <a:solidFill>
+                  <a:srgbClr val="586579"/>
+                </a:solidFill>
+              </a:defRPr>
+            </a:lvl3pPr>
+            <a:lvl4pPr>
+              <a:defRPr sz="1350" b="0">
+                <a:solidFill>
+                  <a:srgbClr val="586579"/>
+                </a:solidFill>
+              </a:defRPr>
+            </a:lvl4pPr>
+            <a:lvl5pPr>
+              <a:defRPr sz="1350" b="0">
+                <a:solidFill>
+                  <a:srgbClr val="586579"/>
+                </a:solidFill>
+              </a:defRPr>
+            </a:lvl5pPr>
+            <a:lvl6pPr>
+              <a:defRPr sz="1350" b="0">
+                <a:solidFill>
+                  <a:srgbClr val="586579"/>
+                </a:solidFill>
+              </a:defRPr>
+            </a:lvl6pPr>
+            <a:lvl7pPr>
+              <a:defRPr sz="1350" b="0">
+                <a:solidFill>
+                  <a:srgbClr val="586579"/>
+                </a:solidFill>
+              </a:defRPr>
+            </a:lvl7pPr>
+            <a:lvl8pPr>
+              <a:defRPr sz="1350" b="0">
+                <a:solidFill>
+                  <a:srgbClr val="586579"/>
+                </a:solidFill>
+              </a:defRPr>
+            </a:lvl8pPr>
+            <a:lvl9pPr>
+              <a:defRPr sz="1350" b="0">
+                <a:solidFill>
+                  <a:srgbClr val="586579"/>
+                </a:solidFill>
+              </a:defRPr>
+            </a:lvl9pPr>
+          </a:lstStyle>
+          <a:p xmlns:a="http://schemas.openxmlformats.org/drawingml/2006/main">
+            <a:pPr>
+              <a:defRPr sz="1350" b="0">
+                <a:solidFill>
+                  <a:srgbClr val="586579"/>
+                </a:solidFill>
+              </a:defRPr>
+            </a:pPr>
+            <a:r>
+              <a:rPr sz="1350" b="0">
+                <a:solidFill>
+                  <a:srgbClr val="586579"/>
+                </a:solidFill>
+              </a:rPr>
+              <a:t>Cercles = responsabilités ; ils ne représentent ni des conteneurs ni l’ordre d’exécution.</a:t>
+            </a:r>
+          </a:p>
+        </p:txBody>
+      </p:sp>
+      <p:sp>
+        <p:nvSpPr>
+          <p:cNvPr id="33" name="">
+            <a:extLst xmlns:a="http://schemas.openxmlformats.org/drawingml/2006/main">
+              <a:ext uri="{FF2B5EF4-FFF2-40B4-BE49-F238E27FC236}">
+                <a16:creationId xmlns:a16="http://schemas.microsoft.com/office/drawing/2014/main" id="{94FD1865-84F9-472E-919E-EB9A552D23D4}"/>
+              </a:ext>
+            </a:extLst>
+          </p:cNvPr>
+          <p:cNvSpPr>
+            <a:spLocks xmlns:a="http://schemas.openxmlformats.org/drawingml/2006/main" noGrp="1"/>
+          </p:cNvSpPr>
+          <p:nvPr/>
+        </p:nvSpPr>
+        <p:spPr>
+          <a:xfrm xmlns:a="http://schemas.openxmlformats.org/drawingml/2006/main">
+            <a:off x="495300" y="6496050"/>
+            <a:ext cx="9525000" cy="238125"/>
+          </a:xfrm>
+          <a:prstGeom xmlns:a="http://schemas.openxmlformats.org/drawingml/2006/main" prst="rect">
+            <a:avLst/>
+          </a:prstGeom>
+          <a:noFill xmlns:a="http://schemas.openxmlformats.org/drawingml/2006/main"/>
+          <a:ln xmlns:a="http://schemas.openxmlformats.org/drawingml/2006/main" w="0">
+            <a:noFill/>
+          </a:ln>
+        </p:spPr>
+        <p:txBody>
+          <a:bodyPr xmlns:a="http://schemas.openxmlformats.org/drawingml/2006/main" lIns="0" tIns="0" rIns="0" bIns="0"/>
+          <a:lstStyle xmlns:a="http://schemas.openxmlformats.org/drawingml/2006/main">
+            <a:defPPr>
+              <a:defRPr sz="1350" b="0">
+                <a:solidFill>
+                  <a:srgbClr val="1466B0"/>
+                </a:solidFill>
+              </a:defRPr>
+            </a:defPPr>
+            <a:lvl1pPr>
+              <a:defRPr sz="1350" b="0">
+                <a:solidFill>
+                  <a:srgbClr val="1466B0"/>
+                </a:solidFill>
+              </a:defRPr>
+            </a:lvl1pPr>
+            <a:lvl2pPr>
+              <a:defRPr sz="1350" b="0">
+                <a:solidFill>
+                  <a:srgbClr val="1466B0"/>
+                </a:solidFill>
+              </a:defRPr>
+            </a:lvl2pPr>
+            <a:lvl3pPr>
+              <a:defRPr sz="1350" b="0">
+                <a:solidFill>
+                  <a:srgbClr val="1466B0"/>
+                </a:solidFill>
+              </a:defRPr>
+            </a:lvl3pPr>
+            <a:lvl4pPr>
+              <a:defRPr sz="1350" b="0">
+                <a:solidFill>
+                  <a:srgbClr val="1466B0"/>
+                </a:solidFill>
+              </a:defRPr>
+            </a:lvl4pPr>
+            <a:lvl5pPr>
+              <a:defRPr sz="1350" b="0">
+                <a:solidFill>
+                  <a:srgbClr val="1466B0"/>
+                </a:solidFill>
+              </a:defRPr>
+            </a:lvl5pPr>
+            <a:lvl6pPr>
+              <a:defRPr sz="1350" b="0">
+                <a:solidFill>
+                  <a:srgbClr val="1466B0"/>
+                </a:solidFill>
+              </a:defRPr>
+            </a:lvl6pPr>
+            <a:lvl7pPr>
+              <a:defRPr sz="1350" b="0">
+                <a:solidFill>
+                  <a:srgbClr val="1466B0"/>
+                </a:solidFill>
+              </a:defRPr>
+            </a:lvl7pPr>
+            <a:lvl8pPr>
+              <a:defRPr sz="1350" b="0">
+                <a:solidFill>
+                  <a:srgbClr val="1466B0"/>
+                </a:solidFill>
+              </a:defRPr>
+            </a:lvl8pPr>
+            <a:lvl9pPr>
+              <a:defRPr sz="1350" b="0">
+                <a:solidFill>
+                  <a:srgbClr val="1466B0"/>
+                </a:solidFill>
+              </a:defRPr>
+            </a:lvl9pPr>
+          </a:lstStyle>
+          <a:p xmlns:a="http://schemas.openxmlformats.org/drawingml/2006/main">
+            <a:pPr>
+              <a:defRPr sz="1350" b="0">
+                <a:solidFill>
+                  <a:srgbClr val="1466B0"/>
+                </a:solidFill>
+              </a:defRPr>
+            </a:pPr>
+            <a:r>
+              <a:rPr sz="1350" b="0">
+                <a:solidFill>
+                  <a:srgbClr val="1466B0"/>
+                </a:solidFill>
+                <a:hlinkClick xmlns:ns0="http://schemas.openxmlformats.org/officeDocument/2006/relationships" ns0:id="rIdTableauInteractif"/>
+              </a:rPr>
+              <a:t>Ouvrir le tableau interactif (accès privé)</a:t>
+            </a:r>
+          </a:p>
+        </p:txBody>
+      </p:sp>
+      <p:sp>
+        <p:nvSpPr>
+          <p:cNvPr id="34" name="">
+            <a:extLst xmlns:a="http://schemas.openxmlformats.org/drawingml/2006/main">
+              <a:ext uri="{FF2B5EF4-FFF2-40B4-BE49-F238E27FC236}">
+                <a16:creationId xmlns:a16="http://schemas.microsoft.com/office/drawing/2014/main" id="{6BEE067F-8DED-4799-97F6-B1745D002BA0}"/>
+              </a:ext>
+            </a:extLst>
+          </p:cNvPr>
+          <p:cNvSpPr>
+            <a:spLocks xmlns:a="http://schemas.openxmlformats.org/drawingml/2006/main" noGrp="1"/>
+          </p:cNvSpPr>
+          <p:nvPr/>
+        </p:nvSpPr>
+        <p:spPr>
+          <a:xfrm xmlns:a="http://schemas.openxmlformats.org/drawingml/2006/main">
+            <a:off x="11334750" y="6486525"/>
+            <a:ext cx="381000" cy="238125"/>
+          </a:xfrm>
+          <a:prstGeom xmlns:a="http://schemas.openxmlformats.org/drawingml/2006/main" prst="rect">
+            <a:avLst/>
+          </a:prstGeom>
+          <a:noFill xmlns:a="http://schemas.openxmlformats.org/drawingml/2006/main"/>
+          <a:ln xmlns:a="http://schemas.openxmlformats.org/drawingml/2006/main" w="0">
+            <a:noFill/>
+          </a:ln>
+        </p:spPr>
+        <p:txBody>
+          <a:bodyPr xmlns:a="http://schemas.openxmlformats.org/drawingml/2006/main" lIns="0" tIns="0" rIns="0" bIns="0"/>
+          <a:lstStyle xmlns:a="http://schemas.openxmlformats.org/drawingml/2006/main">
+            <a:defPPr>
+              <a:defRPr sz="1200" b="0">
+                <a:solidFill>
+                  <a:srgbClr val="586579"/>
+                </a:solidFill>
+              </a:defRPr>
+            </a:defPPr>
+            <a:lvl1pPr>
+              <a:defRPr sz="1200" b="0">
+                <a:solidFill>
+                  <a:srgbClr val="586579"/>
+                </a:solidFill>
+              </a:defRPr>
+            </a:lvl1pPr>
+            <a:lvl2pPr>
+              <a:defRPr sz="1200" b="0">
+                <a:solidFill>
+                  <a:srgbClr val="586579"/>
+                </a:solidFill>
+              </a:defRPr>
+            </a:lvl2pPr>
+            <a:lvl3pPr>
+              <a:defRPr sz="1200" b="0">
+                <a:solidFill>
+                  <a:srgbClr val="586579"/>
+                </a:solidFill>
+              </a:defRPr>
+            </a:lvl3pPr>
+            <a:lvl4pPr>
+              <a:defRPr sz="1200" b="0">
+                <a:solidFill>
+                  <a:srgbClr val="586579"/>
+                </a:solidFill>
+              </a:defRPr>
+            </a:lvl4pPr>
+            <a:lvl5pPr>
+              <a:defRPr sz="1200" b="0">
+                <a:solidFill>
+                  <a:srgbClr val="586579"/>
+                </a:solidFill>
+              </a:defRPr>
+            </a:lvl5pPr>
+            <a:lvl6pPr>
+              <a:defRPr sz="1200" b="0">
+                <a:solidFill>
+                  <a:srgbClr val="586579"/>
+                </a:solidFill>
+              </a:defRPr>
+            </a:lvl6pPr>
+            <a:lvl7pPr>
+              <a:defRPr sz="1200" b="0">
+                <a:solidFill>
+                  <a:srgbClr val="586579"/>
+                </a:solidFill>
+              </a:defRPr>
+            </a:lvl7pPr>
+            <a:lvl8pPr>
+              <a:defRPr sz="1200" b="0">
+                <a:solidFill>
+                  <a:srgbClr val="586579"/>
+                </a:solidFill>
+              </a:defRPr>
+            </a:lvl8pPr>
+            <a:lvl9pPr>
+              <a:defRPr sz="1200" b="0">
+                <a:solidFill>
+                  <a:srgbClr val="586579"/>
+                </a:solidFill>
+              </a:defRPr>
+            </a:lvl9pPr>
+          </a:lstStyle>
+          <a:p xmlns:a="http://schemas.openxmlformats.org/drawingml/2006/main">
+            <a:pPr>
+              <a:defRPr sz="1200" b="0">
+                <a:solidFill>
+                  <a:srgbClr val="586579"/>
+                </a:solidFill>
+              </a:defRPr>
+            </a:pPr>
+            <a:r>
+              <a:rPr sz="1200" b="0">
+                <a:solidFill>
+                  <a:srgbClr val="586579"/>
+                </a:solidFill>
+              </a:rPr>
+              <a:t>16</a:t>
+            </a:r>
+          </a:p>
+        </p:txBody>
+      </p:sp>
+    </p:spTree>
+    <p:extLst>
+      <p:ext uri="{BB962C8B-B14F-4D97-AF65-F5344CB8AC3E}">
+        <p14:creationId xmlns:p14="http://schemas.microsoft.com/office/powerpoint/2010/main" val="261784480"/>
+      </p:ext>
+    </p:extLst>
+  </p:cSld>
+</p:sld>
+</file>
+
 <file path=ppt/slides/slide2.xml><?xml version="1.0" encoding="utf-8"?>
 <p:sld xmlns:p="http://schemas.openxmlformats.org/presentationml/2006/main">
   <p:cSld>

</xml_diff>